<commit_message>
Sim-Review VA07: 10 VPs umgesetzt + Artefakte neu + sim_review ✅
Co-Authored-By: Claude Fable 5 <noreply@anthropic.com>
</commit_message>
<xml_diff>
--- a/protected-downloads/praesentation/VA07.pptx
+++ b/protected-downloads/praesentation/VA07.pptx
@@ -5627,7 +5627,7 @@
                 </a:solidFill>
                 <a:latin typeface="Consolas"/>
               </a:rPr>
-              <a:t>01:05–01:20 </a:t>
+              <a:t>01:05–01:25 </a:t>
             </a:r>
             <a:r>
               <a:rPr sz="1500" b="1">
@@ -5664,7 +5664,7 @@
                 </a:solidFill>
                 <a:latin typeface="Consolas"/>
               </a:rPr>
-              <a:t>01:20–01:25 </a:t>
+              <a:t>01:25–01:30 </a:t>
             </a:r>
             <a:r>
               <a:rPr sz="1500" b="1">
@@ -5673,44 +5673,7 @@
                 </a:solidFill>
                 <a:latin typeface="Arial"/>
               </a:rPr>
-              <a:t>  Reflexion &amp; Transfer</a:t>
-            </a:r>
-            <a:r>
-              <a:rPr sz="1200">
-                <a:solidFill>
-                  <a:srgbClr val="78808C"/>
-                </a:solidFill>
-                <a:latin typeface="Arial"/>
-              </a:rPr>
-              <a:t>  ·  Plenumsgespräch</a:t>
-            </a:r>
-          </a:p>
-          <a:p>
-            <a:pPr>
-              <a:spcBef>
-                <a:spcPts val="700"/>
-              </a:spcBef>
-              <a:spcAft>
-                <a:spcPts val="100"/>
-              </a:spcAft>
-            </a:pPr>
-            <a:r>
-              <a:rPr sz="1200">
-                <a:solidFill>
-                  <a:srgbClr val="78808C"/>
-                </a:solidFill>
-                <a:latin typeface="Consolas"/>
-              </a:rPr>
-              <a:t>01:25–01:30 </a:t>
-            </a:r>
-            <a:r>
-              <a:rPr sz="1500" b="1">
-                <a:solidFill>
-                  <a:srgbClr val="3D5466"/>
-                </a:solidFill>
-                <a:latin typeface="Arial"/>
-              </a:rPr>
-              <a:t>  Abschluss &amp; Ausblick</a:t>
+              <a:t>  Reflexion, Transfer-Anker &amp; Abschluss</a:t>
             </a:r>
             <a:r>
               <a:rPr sz="1200">

</xml_diff>

<commit_message>
Welle 3: VA07 kuratiertes Deck + 2 Schaubilder (Web/Admin/Workbook)
Co-Authored-By: Claude Fable 5 <noreply@anthropic.com>
</commit_message>
<xml_diff>
--- a/protected-downloads/praesentation/VA07.pptx
+++ b/protected-downloads/praesentation/VA07.pptx
@@ -13,6 +13,14 @@
     <p:sldId id="261" r:id="rId13"/>
     <p:sldId id="262" r:id="rId14"/>
     <p:sldId id="263" r:id="rId15"/>
+    <p:sldId id="264" r:id="rId16"/>
+    <p:sldId id="265" r:id="rId17"/>
+    <p:sldId id="266" r:id="rId18"/>
+    <p:sldId id="267" r:id="rId19"/>
+    <p:sldId id="268" r:id="rId20"/>
+    <p:sldId id="269" r:id="rId21"/>
+    <p:sldId id="270" r:id="rId22"/>
+    <p:sldId id="271" r:id="rId23"/>
   </p:sldIdLst>
   <p:sldSz cx="12188952" cy="6858000" type="screen4x3"/>
   <p:notesSz cx="6858000" cy="9144000"/>
@@ -579,7 +587,7 @@
           <a:lstStyle/>
           <a:p>
             <a:r>
-              <a:t>Siehe Trainerhandbuch (Sektion 3) für Moderationshinweise, Timing und erwartete Teilnehmerreaktionen.</a:t>
+              <a:t>Blitzlicht: „Welches Reibungsthema kennen Sie aus Ihrem Alltag – in einem Satz?" Visualisierung: Assistenz in der Mitte, Pfeile von Berater/Teamleitung/Marktfolge. Frage: „Wer sitzt bei Ihnen in diesem Kreis?"</a:t>
             </a:r>
           </a:p>
         </p:txBody>
@@ -649,7 +657,7 @@
           <a:lstStyle/>
           <a:p>
             <a:r>
-              <a:t>Siehe Trainerhandbuch (Sektion 3) für Moderationshinweise, Timing und erwartete Teilnehmerreaktionen.</a:t>
+              <a:t>Kernbotschaft: Konflikte entstehen selten aus schlechtem Willen, sondern aus unklaren Zuständigkeiten. Rollenaushandlung macht sie sichtbar und lösbar.</a:t>
             </a:r>
           </a:p>
         </p:txBody>
@@ -719,27 +727,7 @@
           <a:lstStyle/>
           <a:p>
             <a:r>
-              <a:t>AB-4 Musterlösung (Trainer-Version)</a:t>
-            </a:r>
-          </a:p>
-          <a:p>
-            <a:r>
-              <a:t>Sinnvoll: Berater A zuerst (harter Termin „bis Mittag", konkrete Deadline), transparent an B und C zurückmelden, bis wann sie mit Ergebnissen rechnen können. Berater C (nicht dringend) wird terminiert. Das Missverständnis mit B wird aktiv und ohne Schuldzuweisung geklärt („Ich hatte den Auftrag als X verstanden – lassen Sie uns kurz abgleichen, damit es passt") und künftig durch die Regel „Aufträge ins System + Rückbestätigung" vermieden.</a:t>
-            </a:r>
-          </a:p>
-          <a:p>
-            <a:r>
-              <a:t>Kernbefund: Nicht Lautstärke entscheidet, sondern Deadline und Regel. Die eigentliche Lösung ist präventiv: klare Übergaberegeln verhindern die meisten Konflikte, bevor sie entstehen.</a:t>
-            </a:r>
-          </a:p>
-          <a:p>
-            <a:r>
-              <a:t>Praxishinweis – Wenn ein Berater zugleich Ihre Führungskraft ist: Die faire Aushandlung gilt unter gleichrangigen Beratern. Ist einer davon Ihr Teamleiter, ist seine Anweisung kein Priorisierungskonflikt mehr, sondern eine Weisung – seine Anfragen haben im Zweifel Vorrang. Kommunizieren Sie das transparent gegenüber den anderen Beratern („Ich habe noch eine dringende Aufgabe vom Teamleiter – ich melde mich bis X Uhr bei Ihnen"). Das ist keine Ungerechtigkeit, sondern organisatorische Klarheit.</a:t>
-            </a:r>
-          </a:p>
-          <a:p>
-            <a:r>
-              <a:t>Trainer-Hinweis: Im Rollenspiel die Rückmeldung an die „wartenden" Berater üben – Transparenz ist der Hebel. Achten Sie darauf, dass das Missverständnis mit B sachlich, nicht rechtfertigend geklärt wird (Anschluss an VA05, Beziehung vor Sache).</a:t>
+              <a:t>Überleitung zum Fall: nicht alle Konflikte haben dieselbe Ursache – Zuständigkeit, Information oder Priorität. Die Lösung muss zur Ursache passen.</a:t>
             </a:r>
           </a:p>
         </p:txBody>
@@ -809,7 +797,297 @@
           <a:lstStyle/>
           <a:p>
             <a:r>
-              <a:t>Siehe Trainerhandbuch (Sektion 3) für Moderationshinweise, Timing und erwartete Teilnehmerreaktionen.</a:t>
+              <a:t>Ursachen zuordnen (AB-2): A = Priorität, B = Information/Missverständnis (Zuruf), C = Zuständigkeit/Reihenfolge. Nicht alle drei mit derselben Antwort lösen.</a:t>
+            </a:r>
+          </a:p>
+        </p:txBody>
+      </p:sp>
+      <p:sp>
+        <p:nvSpPr>
+          <p:cNvPr id="4" name="Slide Number Placeholder 3"/>
+          <p:cNvSpPr>
+            <a:spLocks noGrp="1"/>
+          </p:cNvSpPr>
+          <p:nvPr>
+            <p:ph type="sldNum" idx="5" sz="quarter"/>
+          </p:nvPr>
+        </p:nvSpPr>
+        <p:spPr/>
+      </p:sp>
+    </p:spTree>
+  </p:cSld>
+  <p:clrMapOvr>
+    <a:masterClrMapping/>
+  </p:clrMapOvr>
+</p:notes>
+</file>
+
+<file path=ppt/notesSlides/notesSlide6.xml><?xml version="1.0" encoding="utf-8"?>
+<p:notes xmlns:a="http://schemas.openxmlformats.org/drawingml/2006/main" xmlns:p="http://schemas.openxmlformats.org/presentationml/2006/main" xmlns:r="http://schemas.openxmlformats.org/officeDocument/2006/relationships">
+  <p:cSld>
+    <p:spTree>
+      <p:nvGrpSpPr>
+        <p:cNvPr id="1" name=""/>
+        <p:cNvGrpSpPr/>
+        <p:nvPr/>
+      </p:nvGrpSpPr>
+      <p:grpSpPr>
+        <a:xfrm>
+          <a:off x="0" y="0"/>
+          <a:ext cx="0" cy="0"/>
+          <a:chOff x="0" y="0"/>
+          <a:chExt cx="0" cy="0"/>
+        </a:xfrm>
+      </p:grpSpPr>
+      <p:sp>
+        <p:nvSpPr>
+          <p:cNvPr id="2" name="Slide Image Placeholder 1"/>
+          <p:cNvSpPr>
+            <a:spLocks noGrp="1"/>
+          </p:cNvSpPr>
+          <p:nvPr>
+            <p:ph type="sldImg" idx="2"/>
+          </p:nvPr>
+        </p:nvSpPr>
+        <p:spPr/>
+      </p:sp>
+      <p:sp>
+        <p:nvSpPr>
+          <p:cNvPr id="3" name="Notes Placeholder 2"/>
+          <p:cNvSpPr>
+            <a:spLocks noGrp="1"/>
+          </p:cNvSpPr>
+          <p:nvPr>
+            <p:ph type="body" idx="3" sz="quarter"/>
+          </p:nvPr>
+        </p:nvSpPr>
+        <p:spPr/>
+        <p:txBody>
+          <a:bodyPr/>
+          <a:lstStyle/>
+          <a:p>
+            <a:r>
+              <a:t>Priorisieren nach Regel, nicht nach Lautstärke. Rückmelden statt still abarbeiten. Bei echtem Konflikt die Regel gemeinsam mit den Beratern aushandeln.</a:t>
+            </a:r>
+          </a:p>
+        </p:txBody>
+      </p:sp>
+      <p:sp>
+        <p:nvSpPr>
+          <p:cNvPr id="4" name="Slide Number Placeholder 3"/>
+          <p:cNvSpPr>
+            <a:spLocks noGrp="1"/>
+          </p:cNvSpPr>
+          <p:nvPr>
+            <p:ph type="sldNum" idx="5" sz="quarter"/>
+          </p:nvPr>
+        </p:nvSpPr>
+        <p:spPr/>
+      </p:sp>
+    </p:spTree>
+  </p:cSld>
+  <p:clrMapOvr>
+    <a:masterClrMapping/>
+  </p:clrMapOvr>
+</p:notes>
+</file>
+
+<file path=ppt/notesSlides/notesSlide7.xml><?xml version="1.0" encoding="utf-8"?>
+<p:notes xmlns:a="http://schemas.openxmlformats.org/drawingml/2006/main" xmlns:p="http://schemas.openxmlformats.org/presentationml/2006/main" xmlns:r="http://schemas.openxmlformats.org/officeDocument/2006/relationships">
+  <p:cSld>
+    <p:spTree>
+      <p:nvGrpSpPr>
+        <p:cNvPr id="1" name=""/>
+        <p:cNvGrpSpPr/>
+        <p:nvPr/>
+      </p:nvGrpSpPr>
+      <p:grpSpPr>
+        <a:xfrm>
+          <a:off x="0" y="0"/>
+          <a:ext cx="0" cy="0"/>
+          <a:chOff x="0" y="0"/>
+          <a:chExt cx="0" cy="0"/>
+        </a:xfrm>
+      </p:grpSpPr>
+      <p:sp>
+        <p:nvSpPr>
+          <p:cNvPr id="2" name="Slide Image Placeholder 1"/>
+          <p:cNvSpPr>
+            <a:spLocks noGrp="1"/>
+          </p:cNvSpPr>
+          <p:nvPr>
+            <p:ph type="sldImg" idx="2"/>
+          </p:nvPr>
+        </p:nvSpPr>
+        <p:spPr/>
+      </p:sp>
+      <p:sp>
+        <p:nvSpPr>
+          <p:cNvPr id="3" name="Notes Placeholder 2"/>
+          <p:cNvSpPr>
+            <a:spLocks noGrp="1"/>
+          </p:cNvSpPr>
+          <p:nvPr>
+            <p:ph type="body" idx="3" sz="quarter"/>
+          </p:nvPr>
+        </p:nvSpPr>
+        <p:spPr/>
+        <p:txBody>
+          <a:bodyPr/>
+          <a:lstStyle/>
+          <a:p>
+            <a:r>
+              <a:t>AB-2 Musterlösung (Trainer-Version)</a:t>
+            </a:r>
+          </a:p>
+          <a:p>
+            <a:r>
+              <a:t>Ursachen: Berater A = Priorität (Regel anwenden), Berater B = Information (Zuruf → Missverständnis), Berater C = Zuständigkeit/Reihenfolge.</a:t>
+            </a:r>
+          </a:p>
+          <a:p>
+            <a:r>
+              <a:t>Trainer-Hinweis: nach jedem Rollenspiel-Durchgang im Dreier reflektieren – wurde Zustimmung eingeholt? Wurde das Anliegen minimiert?</a:t>
+            </a:r>
+          </a:p>
+        </p:txBody>
+      </p:sp>
+      <p:sp>
+        <p:nvSpPr>
+          <p:cNvPr id="4" name="Slide Number Placeholder 3"/>
+          <p:cNvSpPr>
+            <a:spLocks noGrp="1"/>
+          </p:cNvSpPr>
+          <p:nvPr>
+            <p:ph type="sldNum" idx="5" sz="quarter"/>
+          </p:nvPr>
+        </p:nvSpPr>
+        <p:spPr/>
+      </p:sp>
+    </p:spTree>
+  </p:cSld>
+  <p:clrMapOvr>
+    <a:masterClrMapping/>
+  </p:clrMapOvr>
+</p:notes>
+</file>
+
+<file path=ppt/notesSlides/notesSlide8.xml><?xml version="1.0" encoding="utf-8"?>
+<p:notes xmlns:a="http://schemas.openxmlformats.org/drawingml/2006/main" xmlns:p="http://schemas.openxmlformats.org/presentationml/2006/main" xmlns:r="http://schemas.openxmlformats.org/officeDocument/2006/relationships">
+  <p:cSld>
+    <p:spTree>
+      <p:nvGrpSpPr>
+        <p:cNvPr id="1" name=""/>
+        <p:cNvGrpSpPr/>
+        <p:nvPr/>
+      </p:nvGrpSpPr>
+      <p:grpSpPr>
+        <a:xfrm>
+          <a:off x="0" y="0"/>
+          <a:ext cx="0" cy="0"/>
+          <a:chOff x="0" y="0"/>
+          <a:chExt cx="0" cy="0"/>
+        </a:xfrm>
+      </p:grpSpPr>
+      <p:sp>
+        <p:nvSpPr>
+          <p:cNvPr id="2" name="Slide Image Placeholder 1"/>
+          <p:cNvSpPr>
+            <a:spLocks noGrp="1"/>
+          </p:cNvSpPr>
+          <p:nvPr>
+            <p:ph type="sldImg" idx="2"/>
+          </p:nvPr>
+        </p:nvSpPr>
+        <p:spPr/>
+      </p:sp>
+      <p:sp>
+        <p:nvSpPr>
+          <p:cNvPr id="3" name="Notes Placeholder 2"/>
+          <p:cNvSpPr>
+            <a:spLocks noGrp="1"/>
+          </p:cNvSpPr>
+          <p:nvPr>
+            <p:ph type="body" idx="3" sz="quarter"/>
+          </p:nvPr>
+        </p:nvSpPr>
+        <p:spPr/>
+        <p:txBody>
+          <a:bodyPr/>
+          <a:lstStyle/>
+          <a:p>
+            <a:r>
+              <a:t>Transfer-Anker: Sec 5.1 öffnen, den Reibungspunkt aus AB-1 und den Namen der Person eintragen, mit der man sprechen wird. Ausblick VA09 (Co-Pilot-Stufe).</a:t>
+            </a:r>
+          </a:p>
+        </p:txBody>
+      </p:sp>
+      <p:sp>
+        <p:nvSpPr>
+          <p:cNvPr id="4" name="Slide Number Placeholder 3"/>
+          <p:cNvSpPr>
+            <a:spLocks noGrp="1"/>
+          </p:cNvSpPr>
+          <p:nvPr>
+            <p:ph type="sldNum" idx="5" sz="quarter"/>
+          </p:nvPr>
+        </p:nvSpPr>
+        <p:spPr/>
+      </p:sp>
+    </p:spTree>
+  </p:cSld>
+  <p:clrMapOvr>
+    <a:masterClrMapping/>
+  </p:clrMapOvr>
+</p:notes>
+</file>
+
+<file path=ppt/notesSlides/notesSlide9.xml><?xml version="1.0" encoding="utf-8"?>
+<p:notes xmlns:a="http://schemas.openxmlformats.org/drawingml/2006/main" xmlns:p="http://schemas.openxmlformats.org/presentationml/2006/main" xmlns:r="http://schemas.openxmlformats.org/officeDocument/2006/relationships">
+  <p:cSld>
+    <p:spTree>
+      <p:nvGrpSpPr>
+        <p:cNvPr id="1" name=""/>
+        <p:cNvGrpSpPr/>
+        <p:nvPr/>
+      </p:nvGrpSpPr>
+      <p:grpSpPr>
+        <a:xfrm>
+          <a:off x="0" y="0"/>
+          <a:ext cx="0" cy="0"/>
+          <a:chOff x="0" y="0"/>
+          <a:chExt cx="0" cy="0"/>
+        </a:xfrm>
+      </p:grpSpPr>
+      <p:sp>
+        <p:nvSpPr>
+          <p:cNvPr id="2" name="Slide Image Placeholder 1"/>
+          <p:cNvSpPr>
+            <a:spLocks noGrp="1"/>
+          </p:cNvSpPr>
+          <p:nvPr>
+            <p:ph type="sldImg" idx="2"/>
+          </p:nvPr>
+        </p:nvSpPr>
+        <p:spPr/>
+      </p:sp>
+      <p:sp>
+        <p:nvSpPr>
+          <p:cNvPr id="3" name="Notes Placeholder 2"/>
+          <p:cNvSpPr>
+            <a:spLocks noGrp="1"/>
+          </p:cNvSpPr>
+          <p:nvPr>
+            <p:ph type="body" idx="3" sz="quarter"/>
+          </p:nvPr>
+        </p:nvSpPr>
+        <p:spPr/>
+        <p:txBody>
+          <a:bodyPr/>
+          <a:lstStyle/>
+          <a:p>
+            <a:r>
+              <a:t>Fragen 2 und 3 kurz im Plenum. Karte „Gute Zusammenarbeit" (AB-5) übergeben.</a:t>
             </a:r>
           </a:p>
         </p:txBody>
@@ -4380,6 +4658,2829 @@
 </p:sld>
 </file>
 
+<file path=ppt/slides/slide10.xml><?xml version="1.0" encoding="utf-8"?>
+<p:sld xmlns:a="http://schemas.openxmlformats.org/drawingml/2006/main" xmlns:p="http://schemas.openxmlformats.org/presentationml/2006/main" xmlns:r="http://schemas.openxmlformats.org/officeDocument/2006/relationships">
+  <p:cSld>
+    <p:spTree>
+      <p:nvGrpSpPr>
+        <p:cNvPr id="1" name=""/>
+        <p:cNvGrpSpPr/>
+        <p:nvPr/>
+      </p:nvGrpSpPr>
+      <p:grpSpPr/>
+      <p:sp>
+        <p:nvSpPr>
+          <p:cNvPr id="2" name="Rectangle 1"/>
+          <p:cNvSpPr/>
+          <p:nvPr/>
+        </p:nvSpPr>
+        <p:spPr>
+          <a:xfrm>
+            <a:off x="0" y="0"/>
+            <a:ext cx="12188952" cy="6858000"/>
+          </a:xfrm>
+          <a:prstGeom prst="rect">
+            <a:avLst/>
+          </a:prstGeom>
+          <a:solidFill>
+            <a:srgbClr val="FFFFFF"/>
+          </a:solidFill>
+          <a:ln>
+            <a:noFill/>
+          </a:ln>
+        </p:spPr>
+        <p:style>
+          <a:lnRef idx="1">
+            <a:schemeClr val="accent1"/>
+          </a:lnRef>
+          <a:fillRef idx="3">
+            <a:schemeClr val="accent1"/>
+          </a:fillRef>
+          <a:effectRef idx="2">
+            <a:schemeClr val="accent1"/>
+          </a:effectRef>
+          <a:fontRef idx="minor">
+            <a:schemeClr val="lt1"/>
+          </a:fontRef>
+        </p:style>
+        <p:txBody>
+          <a:bodyPr rtlCol="0" anchor="ctr"/>
+          <a:lstStyle/>
+          <a:p>
+            <a:pPr algn="ctr"/>
+          </a:p>
+        </p:txBody>
+      </p:sp>
+      <p:sp>
+        <p:nvSpPr>
+          <p:cNvPr id="3" name="Rectangle 2"/>
+          <p:cNvSpPr/>
+          <p:nvPr/>
+        </p:nvSpPr>
+        <p:spPr>
+          <a:xfrm>
+            <a:off x="0" y="0"/>
+            <a:ext cx="12188952" cy="50292"/>
+          </a:xfrm>
+          <a:prstGeom prst="rect">
+            <a:avLst/>
+          </a:prstGeom>
+          <a:solidFill>
+            <a:srgbClr val="1F2C56"/>
+          </a:solidFill>
+          <a:ln>
+            <a:noFill/>
+          </a:ln>
+        </p:spPr>
+        <p:style>
+          <a:lnRef idx="1">
+            <a:schemeClr val="accent1"/>
+          </a:lnRef>
+          <a:fillRef idx="3">
+            <a:schemeClr val="accent1"/>
+          </a:fillRef>
+          <a:effectRef idx="2">
+            <a:schemeClr val="accent1"/>
+          </a:effectRef>
+          <a:fontRef idx="minor">
+            <a:schemeClr val="lt1"/>
+          </a:fontRef>
+        </p:style>
+        <p:txBody>
+          <a:bodyPr rtlCol="0" anchor="ctr"/>
+          <a:lstStyle/>
+          <a:p>
+            <a:pPr algn="ctr"/>
+          </a:p>
+        </p:txBody>
+      </p:sp>
+      <p:sp>
+        <p:nvSpPr>
+          <p:cNvPr id="4" name="TextBox 3"/>
+          <p:cNvSpPr txBox="1"/>
+          <p:nvPr/>
+        </p:nvSpPr>
+        <p:spPr>
+          <a:xfrm>
+            <a:off x="685800" y="109728"/>
+            <a:ext cx="10817352" cy="228600"/>
+          </a:xfrm>
+          <a:prstGeom prst="rect">
+            <a:avLst/>
+          </a:prstGeom>
+          <a:noFill/>
+        </p:spPr>
+        <p:txBody>
+          <a:bodyPr wrap="none">
+            <a:spAutoFit/>
+          </a:bodyPr>
+          <a:lstStyle/>
+          <a:p>
+            <a:pPr algn="l"/>
+            <a:r>
+              <a:rPr sz="750">
+                <a:solidFill>
+                  <a:srgbClr val="78808C"/>
+                </a:solidFill>
+                <a:latin typeface="Consolas"/>
+              </a:rPr>
+              <a:t>VA07  ·  SCHAUBILD</a:t>
+            </a:r>
+          </a:p>
+        </p:txBody>
+      </p:sp>
+      <p:sp>
+        <p:nvSpPr>
+          <p:cNvPr id="5" name="TextBox 4"/>
+          <p:cNvSpPr txBox="1"/>
+          <p:nvPr/>
+        </p:nvSpPr>
+        <p:spPr>
+          <a:xfrm>
+            <a:off x="685800" y="502920"/>
+            <a:ext cx="10817352" cy="594360"/>
+          </a:xfrm>
+          <a:prstGeom prst="rect">
+            <a:avLst/>
+          </a:prstGeom>
+          <a:noFill/>
+        </p:spPr>
+        <p:txBody>
+          <a:bodyPr wrap="square">
+            <a:spAutoFit/>
+          </a:bodyPr>
+          <a:lstStyle/>
+          <a:p>
+            <a:pPr algn="l"/>
+            <a:r>
+              <a:rPr sz="2000" b="1" i="0">
+                <a:solidFill>
+                  <a:srgbClr val="1F2C56"/>
+                </a:solidFill>
+                <a:latin typeface="Arial"/>
+              </a:rPr>
+              <a:t>Wenn mehrere gleichzeitig „dringend" sagen</a:t>
+            </a:r>
+          </a:p>
+        </p:txBody>
+      </p:sp>
+      <p:sp>
+        <p:nvSpPr>
+          <p:cNvPr id="6" name="Rectangle 5"/>
+          <p:cNvSpPr/>
+          <p:nvPr/>
+        </p:nvSpPr>
+        <p:spPr>
+          <a:xfrm>
+            <a:off x="685800" y="1143000"/>
+            <a:ext cx="10817352" cy="25400"/>
+          </a:xfrm>
+          <a:prstGeom prst="rect">
+            <a:avLst/>
+          </a:prstGeom>
+          <a:solidFill>
+            <a:srgbClr val="D9C089"/>
+          </a:solidFill>
+          <a:ln>
+            <a:noFill/>
+          </a:ln>
+        </p:spPr>
+        <p:style>
+          <a:lnRef idx="1">
+            <a:schemeClr val="accent1"/>
+          </a:lnRef>
+          <a:fillRef idx="3">
+            <a:schemeClr val="accent1"/>
+          </a:fillRef>
+          <a:effectRef idx="2">
+            <a:schemeClr val="accent1"/>
+          </a:effectRef>
+          <a:fontRef idx="minor">
+            <a:schemeClr val="lt1"/>
+          </a:fontRef>
+        </p:style>
+        <p:txBody>
+          <a:bodyPr rtlCol="0" anchor="ctr"/>
+          <a:lstStyle/>
+          <a:p>
+            <a:pPr algn="ctr"/>
+          </a:p>
+        </p:txBody>
+      </p:sp>
+      <p:pic>
+        <p:nvPicPr>
+          <p:cNvPr id="7" name="Picture 6" descr="image.png"/>
+          <p:cNvPicPr>
+            <a:picLocks noChangeAspect="1"/>
+          </p:cNvPicPr>
+          <p:nvPr/>
+        </p:nvPicPr>
+        <p:blipFill>
+          <a:blip r:embed="rId2"/>
+          <a:stretch>
+            <a:fillRect/>
+          </a:stretch>
+        </p:blipFill>
+        <p:spPr>
+          <a:xfrm>
+            <a:off x="2009463" y="1325880"/>
+            <a:ext cx="8170026" cy="4937760"/>
+          </a:xfrm>
+          <a:prstGeom prst="rect">
+            <a:avLst/>
+          </a:prstGeom>
+        </p:spPr>
+      </p:pic>
+      <p:sp>
+        <p:nvSpPr>
+          <p:cNvPr id="8" name="Rectangle 7"/>
+          <p:cNvSpPr/>
+          <p:nvPr/>
+        </p:nvSpPr>
+        <p:spPr>
+          <a:xfrm>
+            <a:off x="0" y="6510528"/>
+            <a:ext cx="12188952" cy="347472"/>
+          </a:xfrm>
+          <a:prstGeom prst="rect">
+            <a:avLst/>
+          </a:prstGeom>
+          <a:solidFill>
+            <a:srgbClr val="0A1937"/>
+          </a:solidFill>
+          <a:ln>
+            <a:noFill/>
+          </a:ln>
+        </p:spPr>
+        <p:style>
+          <a:lnRef idx="1">
+            <a:schemeClr val="accent1"/>
+          </a:lnRef>
+          <a:fillRef idx="3">
+            <a:schemeClr val="accent1"/>
+          </a:fillRef>
+          <a:effectRef idx="2">
+            <a:schemeClr val="accent1"/>
+          </a:effectRef>
+          <a:fontRef idx="minor">
+            <a:schemeClr val="lt1"/>
+          </a:fontRef>
+        </p:style>
+        <p:txBody>
+          <a:bodyPr rtlCol="0" anchor="ctr"/>
+          <a:lstStyle/>
+          <a:p>
+            <a:pPr algn="ctr"/>
+          </a:p>
+        </p:txBody>
+      </p:sp>
+      <p:sp>
+        <p:nvSpPr>
+          <p:cNvPr id="9" name="TextBox 8"/>
+          <p:cNvSpPr txBox="1"/>
+          <p:nvPr/>
+        </p:nvSpPr>
+        <p:spPr>
+          <a:xfrm>
+            <a:off x="685800" y="6583680"/>
+            <a:ext cx="6490411" cy="256032"/>
+          </a:xfrm>
+          <a:prstGeom prst="rect">
+            <a:avLst/>
+          </a:prstGeom>
+          <a:noFill/>
+        </p:spPr>
+        <p:txBody>
+          <a:bodyPr wrap="none">
+            <a:spAutoFit/>
+          </a:bodyPr>
+          <a:lstStyle/>
+          <a:p>
+            <a:pPr algn="l"/>
+            <a:r>
+              <a:rPr sz="700">
+                <a:solidFill>
+                  <a:srgbClr val="A0B4D2"/>
+                </a:solidFill>
+                <a:latin typeface="Consolas"/>
+              </a:rPr>
+              <a:t>FKB Campus  ·  VA07</a:t>
+            </a:r>
+          </a:p>
+        </p:txBody>
+      </p:sp>
+      <p:sp>
+        <p:nvSpPr>
+          <p:cNvPr id="10" name="TextBox 9"/>
+          <p:cNvSpPr txBox="1"/>
+          <p:nvPr/>
+        </p:nvSpPr>
+        <p:spPr>
+          <a:xfrm>
+            <a:off x="7176211" y="6583680"/>
+            <a:ext cx="4326940" cy="256032"/>
+          </a:xfrm>
+          <a:prstGeom prst="rect">
+            <a:avLst/>
+          </a:prstGeom>
+          <a:noFill/>
+        </p:spPr>
+        <p:txBody>
+          <a:bodyPr wrap="none">
+            <a:spAutoFit/>
+          </a:bodyPr>
+          <a:lstStyle/>
+          <a:p>
+            <a:pPr algn="r"/>
+            <a:r>
+              <a:rPr sz="700">
+                <a:solidFill>
+                  <a:srgbClr val="A0B4D2"/>
+                </a:solidFill>
+                <a:latin typeface="Consolas"/>
+              </a:rPr>
+              <a:t>Schaubild</a:t>
+            </a:r>
+          </a:p>
+        </p:txBody>
+      </p:sp>
+    </p:spTree>
+  </p:cSld>
+  <p:clrMapOvr>
+    <a:masterClrMapping/>
+  </p:clrMapOvr>
+</p:sld>
+</file>
+
+<file path=ppt/slides/slide11.xml><?xml version="1.0" encoding="utf-8"?>
+<p:sld xmlns:a="http://schemas.openxmlformats.org/drawingml/2006/main" xmlns:p="http://schemas.openxmlformats.org/presentationml/2006/main" xmlns:r="http://schemas.openxmlformats.org/officeDocument/2006/relationships">
+  <p:cSld>
+    <p:spTree>
+      <p:nvGrpSpPr>
+        <p:cNvPr id="1" name=""/>
+        <p:cNvGrpSpPr/>
+        <p:nvPr/>
+      </p:nvGrpSpPr>
+      <p:grpSpPr/>
+      <p:sp>
+        <p:nvSpPr>
+          <p:cNvPr id="2" name="Rectangle 1"/>
+          <p:cNvSpPr/>
+          <p:nvPr/>
+        </p:nvSpPr>
+        <p:spPr>
+          <a:xfrm>
+            <a:off x="0" y="0"/>
+            <a:ext cx="12188952" cy="6858000"/>
+          </a:xfrm>
+          <a:prstGeom prst="rect">
+            <a:avLst/>
+          </a:prstGeom>
+          <a:solidFill>
+            <a:srgbClr val="1F2C56"/>
+          </a:solidFill>
+          <a:ln>
+            <a:noFill/>
+          </a:ln>
+        </p:spPr>
+        <p:style>
+          <a:lnRef idx="1">
+            <a:schemeClr val="accent1"/>
+          </a:lnRef>
+          <a:fillRef idx="3">
+            <a:schemeClr val="accent1"/>
+          </a:fillRef>
+          <a:effectRef idx="2">
+            <a:schemeClr val="accent1"/>
+          </a:effectRef>
+          <a:fontRef idx="minor">
+            <a:schemeClr val="lt1"/>
+          </a:fontRef>
+        </p:style>
+        <p:txBody>
+          <a:bodyPr rtlCol="0" anchor="ctr"/>
+          <a:lstStyle/>
+          <a:p>
+            <a:pPr algn="ctr"/>
+          </a:p>
+        </p:txBody>
+      </p:sp>
+      <p:sp>
+        <p:nvSpPr>
+          <p:cNvPr id="3" name="TextBox 2"/>
+          <p:cNvSpPr txBox="1"/>
+          <p:nvPr/>
+        </p:nvSpPr>
+        <p:spPr>
+          <a:xfrm>
+            <a:off x="685800" y="2377440"/>
+            <a:ext cx="10817352" cy="365760"/>
+          </a:xfrm>
+          <a:prstGeom prst="rect">
+            <a:avLst/>
+          </a:prstGeom>
+          <a:noFill/>
+        </p:spPr>
+        <p:txBody>
+          <a:bodyPr wrap="none">
+            <a:spAutoFit/>
+          </a:bodyPr>
+          <a:lstStyle/>
+          <a:p>
+            <a:pPr algn="l"/>
+            <a:r>
+              <a:rPr sz="1200">
+                <a:solidFill>
+                  <a:srgbClr val="D9C089"/>
+                </a:solidFill>
+                <a:latin typeface="Consolas"/>
+              </a:rPr>
+              <a:t>00:30–01:25</a:t>
+            </a:r>
+          </a:p>
+        </p:txBody>
+      </p:sp>
+      <p:sp>
+        <p:nvSpPr>
+          <p:cNvPr id="4" name="Rectangle 3"/>
+          <p:cNvSpPr/>
+          <p:nvPr/>
+        </p:nvSpPr>
+        <p:spPr>
+          <a:xfrm>
+            <a:off x="685800" y="2788920"/>
+            <a:ext cx="548640" cy="38100"/>
+          </a:xfrm>
+          <a:prstGeom prst="rect">
+            <a:avLst/>
+          </a:prstGeom>
+          <a:solidFill>
+            <a:srgbClr val="D9C089"/>
+          </a:solidFill>
+          <a:ln>
+            <a:noFill/>
+          </a:ln>
+        </p:spPr>
+        <p:style>
+          <a:lnRef idx="1">
+            <a:schemeClr val="accent1"/>
+          </a:lnRef>
+          <a:fillRef idx="3">
+            <a:schemeClr val="accent1"/>
+          </a:fillRef>
+          <a:effectRef idx="2">
+            <a:schemeClr val="accent1"/>
+          </a:effectRef>
+          <a:fontRef idx="minor">
+            <a:schemeClr val="lt1"/>
+          </a:fontRef>
+        </p:style>
+        <p:txBody>
+          <a:bodyPr rtlCol="0" anchor="ctr"/>
+          <a:lstStyle/>
+          <a:p>
+            <a:pPr algn="ctr"/>
+          </a:p>
+        </p:txBody>
+      </p:sp>
+      <p:sp>
+        <p:nvSpPr>
+          <p:cNvPr id="5" name="TextBox 4"/>
+          <p:cNvSpPr txBox="1"/>
+          <p:nvPr/>
+        </p:nvSpPr>
+        <p:spPr>
+          <a:xfrm>
+            <a:off x="685800" y="3017520"/>
+            <a:ext cx="10817352" cy="1463040"/>
+          </a:xfrm>
+          <a:prstGeom prst="rect">
+            <a:avLst/>
+          </a:prstGeom>
+          <a:noFill/>
+        </p:spPr>
+        <p:txBody>
+          <a:bodyPr wrap="square">
+            <a:spAutoFit/>
+          </a:bodyPr>
+          <a:lstStyle/>
+          <a:p>
+            <a:pPr algn="l"/>
+            <a:r>
+              <a:rPr sz="4000" b="1" i="0">
+                <a:solidFill>
+                  <a:srgbClr val="FFFFFF"/>
+                </a:solidFill>
+                <a:latin typeface="Arial"/>
+              </a:rPr>
+              <a:t>Fallübergabe &amp; Fallarbeit</a:t>
+            </a:r>
+          </a:p>
+        </p:txBody>
+      </p:sp>
+      <p:sp>
+        <p:nvSpPr>
+          <p:cNvPr id="6" name="TextBox 5"/>
+          <p:cNvSpPr txBox="1"/>
+          <p:nvPr/>
+        </p:nvSpPr>
+        <p:spPr>
+          <a:xfrm>
+            <a:off x="685800" y="4480560"/>
+            <a:ext cx="8653881" cy="1280160"/>
+          </a:xfrm>
+          <a:prstGeom prst="rect">
+            <a:avLst/>
+          </a:prstGeom>
+          <a:noFill/>
+        </p:spPr>
+        <p:txBody>
+          <a:bodyPr wrap="square">
+            <a:spAutoFit/>
+          </a:bodyPr>
+          <a:lstStyle/>
+          <a:p>
+            <a:pPr algn="l"/>
+            <a:r>
+              <a:rPr sz="1600" b="0" i="0">
+                <a:solidFill>
+                  <a:srgbClr val="C8D2E6"/>
+                </a:solidFill>
+                <a:latin typeface="Arial"/>
+              </a:rPr>
+              <a:t>Drei Berater, ein Vormittag – erst die Ursache erkennen, dann entscheiden.</a:t>
+            </a:r>
+          </a:p>
+        </p:txBody>
+      </p:sp>
+      <p:sp>
+        <p:nvSpPr>
+          <p:cNvPr id="7" name="TextBox 6"/>
+          <p:cNvSpPr txBox="1"/>
+          <p:nvPr/>
+        </p:nvSpPr>
+        <p:spPr>
+          <a:xfrm>
+            <a:off x="685800" y="6355080"/>
+            <a:ext cx="10817352" cy="274320"/>
+          </a:xfrm>
+          <a:prstGeom prst="rect">
+            <a:avLst/>
+          </a:prstGeom>
+          <a:noFill/>
+        </p:spPr>
+        <p:txBody>
+          <a:bodyPr wrap="none">
+            <a:spAutoFit/>
+          </a:bodyPr>
+          <a:lstStyle/>
+          <a:p>
+            <a:pPr algn="l"/>
+            <a:r>
+              <a:rPr sz="700">
+                <a:solidFill>
+                  <a:srgbClr val="8CA0C3"/>
+                </a:solidFill>
+                <a:latin typeface="Consolas"/>
+              </a:rPr>
+              <a:t>FKB Campus  ·  VA07</a:t>
+            </a:r>
+          </a:p>
+        </p:txBody>
+      </p:sp>
+    </p:spTree>
+  </p:cSld>
+  <p:clrMapOvr>
+    <a:masterClrMapping/>
+  </p:clrMapOvr>
+</p:sld>
+</file>
+
+<file path=ppt/slides/slide12.xml><?xml version="1.0" encoding="utf-8"?>
+<p:sld xmlns:a="http://schemas.openxmlformats.org/drawingml/2006/main" xmlns:p="http://schemas.openxmlformats.org/presentationml/2006/main" xmlns:r="http://schemas.openxmlformats.org/officeDocument/2006/relationships">
+  <p:cSld>
+    <p:spTree>
+      <p:nvGrpSpPr>
+        <p:cNvPr id="1" name=""/>
+        <p:cNvGrpSpPr/>
+        <p:nvPr/>
+      </p:nvGrpSpPr>
+      <p:grpSpPr/>
+      <p:sp>
+        <p:nvSpPr>
+          <p:cNvPr id="2" name="Rectangle 1"/>
+          <p:cNvSpPr/>
+          <p:nvPr/>
+        </p:nvSpPr>
+        <p:spPr>
+          <a:xfrm>
+            <a:off x="0" y="0"/>
+            <a:ext cx="12188952" cy="6858000"/>
+          </a:xfrm>
+          <a:prstGeom prst="rect">
+            <a:avLst/>
+          </a:prstGeom>
+          <a:solidFill>
+            <a:srgbClr val="EDEDF3"/>
+          </a:solidFill>
+          <a:ln>
+            <a:noFill/>
+          </a:ln>
+        </p:spPr>
+        <p:style>
+          <a:lnRef idx="1">
+            <a:schemeClr val="accent1"/>
+          </a:lnRef>
+          <a:fillRef idx="3">
+            <a:schemeClr val="accent1"/>
+          </a:fillRef>
+          <a:effectRef idx="2">
+            <a:schemeClr val="accent1"/>
+          </a:effectRef>
+          <a:fontRef idx="minor">
+            <a:schemeClr val="lt1"/>
+          </a:fontRef>
+        </p:style>
+        <p:txBody>
+          <a:bodyPr rtlCol="0" anchor="ctr"/>
+          <a:lstStyle/>
+          <a:p>
+            <a:pPr algn="ctr"/>
+          </a:p>
+        </p:txBody>
+      </p:sp>
+      <p:sp>
+        <p:nvSpPr>
+          <p:cNvPr id="3" name="Rectangle 2"/>
+          <p:cNvSpPr/>
+          <p:nvPr/>
+        </p:nvSpPr>
+        <p:spPr>
+          <a:xfrm>
+            <a:off x="0" y="0"/>
+            <a:ext cx="12188952" cy="50292"/>
+          </a:xfrm>
+          <a:prstGeom prst="rect">
+            <a:avLst/>
+          </a:prstGeom>
+          <a:solidFill>
+            <a:srgbClr val="1F2C56"/>
+          </a:solidFill>
+          <a:ln>
+            <a:noFill/>
+          </a:ln>
+        </p:spPr>
+        <p:style>
+          <a:lnRef idx="1">
+            <a:schemeClr val="accent1"/>
+          </a:lnRef>
+          <a:fillRef idx="3">
+            <a:schemeClr val="accent1"/>
+          </a:fillRef>
+          <a:effectRef idx="2">
+            <a:schemeClr val="accent1"/>
+          </a:effectRef>
+          <a:fontRef idx="minor">
+            <a:schemeClr val="lt1"/>
+          </a:fontRef>
+        </p:style>
+        <p:txBody>
+          <a:bodyPr rtlCol="0" anchor="ctr"/>
+          <a:lstStyle/>
+          <a:p>
+            <a:pPr algn="ctr"/>
+          </a:p>
+        </p:txBody>
+      </p:sp>
+      <p:sp>
+        <p:nvSpPr>
+          <p:cNvPr id="4" name="TextBox 3"/>
+          <p:cNvSpPr txBox="1"/>
+          <p:nvPr/>
+        </p:nvSpPr>
+        <p:spPr>
+          <a:xfrm>
+            <a:off x="685800" y="109728"/>
+            <a:ext cx="10817352" cy="228600"/>
+          </a:xfrm>
+          <a:prstGeom prst="rect">
+            <a:avLst/>
+          </a:prstGeom>
+          <a:noFill/>
+        </p:spPr>
+        <p:txBody>
+          <a:bodyPr wrap="none">
+            <a:spAutoFit/>
+          </a:bodyPr>
+          <a:lstStyle/>
+          <a:p>
+            <a:pPr algn="l"/>
+            <a:r>
+              <a:rPr sz="750">
+                <a:solidFill>
+                  <a:srgbClr val="78808C"/>
+                </a:solidFill>
+                <a:latin typeface="Consolas"/>
+              </a:rPr>
+              <a:t>VA07  ·  INHALT</a:t>
+            </a:r>
+          </a:p>
+        </p:txBody>
+      </p:sp>
+      <p:sp>
+        <p:nvSpPr>
+          <p:cNvPr id="5" name="Rectangle 4"/>
+          <p:cNvSpPr/>
+          <p:nvPr/>
+        </p:nvSpPr>
+        <p:spPr>
+          <a:xfrm>
+            <a:off x="0" y="1234440"/>
+            <a:ext cx="12188952" cy="12700"/>
+          </a:xfrm>
+          <a:prstGeom prst="rect">
+            <a:avLst/>
+          </a:prstGeom>
+          <a:solidFill>
+            <a:srgbClr val="D8DFE4"/>
+          </a:solidFill>
+          <a:ln>
+            <a:noFill/>
+          </a:ln>
+        </p:spPr>
+        <p:style>
+          <a:lnRef idx="1">
+            <a:schemeClr val="accent1"/>
+          </a:lnRef>
+          <a:fillRef idx="3">
+            <a:schemeClr val="accent1"/>
+          </a:fillRef>
+          <a:effectRef idx="2">
+            <a:schemeClr val="accent1"/>
+          </a:effectRef>
+          <a:fontRef idx="minor">
+            <a:schemeClr val="lt1"/>
+          </a:fontRef>
+        </p:style>
+        <p:txBody>
+          <a:bodyPr rtlCol="0" anchor="ctr"/>
+          <a:lstStyle/>
+          <a:p>
+            <a:pPr algn="ctr"/>
+          </a:p>
+        </p:txBody>
+      </p:sp>
+      <p:sp>
+        <p:nvSpPr>
+          <p:cNvPr id="6" name="Rectangle 5"/>
+          <p:cNvSpPr/>
+          <p:nvPr/>
+        </p:nvSpPr>
+        <p:spPr>
+          <a:xfrm>
+            <a:off x="685800" y="502920"/>
+            <a:ext cx="36576" cy="658368"/>
+          </a:xfrm>
+          <a:prstGeom prst="rect">
+            <a:avLst/>
+          </a:prstGeom>
+          <a:solidFill>
+            <a:srgbClr val="D9C089"/>
+          </a:solidFill>
+          <a:ln>
+            <a:noFill/>
+          </a:ln>
+        </p:spPr>
+        <p:style>
+          <a:lnRef idx="1">
+            <a:schemeClr val="accent1"/>
+          </a:lnRef>
+          <a:fillRef idx="3">
+            <a:schemeClr val="accent1"/>
+          </a:fillRef>
+          <a:effectRef idx="2">
+            <a:schemeClr val="accent1"/>
+          </a:effectRef>
+          <a:fontRef idx="minor">
+            <a:schemeClr val="lt1"/>
+          </a:fontRef>
+        </p:style>
+        <p:txBody>
+          <a:bodyPr rtlCol="0" anchor="ctr"/>
+          <a:lstStyle/>
+          <a:p>
+            <a:pPr algn="ctr"/>
+          </a:p>
+        </p:txBody>
+      </p:sp>
+      <p:sp>
+        <p:nvSpPr>
+          <p:cNvPr id="7" name="TextBox 6"/>
+          <p:cNvSpPr txBox="1"/>
+          <p:nvPr/>
+        </p:nvSpPr>
+        <p:spPr>
+          <a:xfrm>
+            <a:off x="813816" y="502920"/>
+            <a:ext cx="10634472" cy="685800"/>
+          </a:xfrm>
+          <a:prstGeom prst="rect">
+            <a:avLst/>
+          </a:prstGeom>
+          <a:noFill/>
+        </p:spPr>
+        <p:txBody>
+          <a:bodyPr wrap="square">
+            <a:spAutoFit/>
+          </a:bodyPr>
+          <a:lstStyle/>
+          <a:p>
+            <a:pPr algn="l"/>
+            <a:r>
+              <a:rPr sz="2400" b="1" i="0">
+                <a:solidFill>
+                  <a:srgbClr val="1F2C56"/>
+                </a:solidFill>
+                <a:latin typeface="Arial"/>
+              </a:rPr>
+              <a:t>Praxisfall: Drei Berater, ein Vormittag</a:t>
+            </a:r>
+          </a:p>
+        </p:txBody>
+      </p:sp>
+      <p:sp>
+        <p:nvSpPr>
+          <p:cNvPr id="8" name="TextBox 7"/>
+          <p:cNvSpPr txBox="1"/>
+          <p:nvPr/>
+        </p:nvSpPr>
+        <p:spPr>
+          <a:xfrm>
+            <a:off x="685800" y="1417320"/>
+            <a:ext cx="10817352" cy="4892040"/>
+          </a:xfrm>
+          <a:prstGeom prst="rect">
+            <a:avLst/>
+          </a:prstGeom>
+          <a:noFill/>
+        </p:spPr>
+        <p:txBody>
+          <a:bodyPr wrap="square">
+            <a:spAutoFit/>
+          </a:bodyPr>
+          <a:lstStyle/>
+          <a:p>
+            <a:pPr>
+              <a:spcBef>
+                <a:spcPts val="1000"/>
+              </a:spcBef>
+              <a:spcAft>
+                <a:spcPts val="200"/>
+              </a:spcAft>
+            </a:pPr>
+            <a:r>
+              <a:rPr sz="800" b="1">
+                <a:solidFill>
+                  <a:srgbClr val="78808C"/>
+                </a:solidFill>
+                <a:latin typeface="Consolas"/>
+              </a:rPr>
+              <a:t>IHR VORMITTAG MIT DREI BERATERN</a:t>
+            </a:r>
+          </a:p>
+          <a:p>
+            <a:pPr marL="190500" indent="-190500">
+              <a:spcBef>
+                <a:spcPts val="400"/>
+              </a:spcBef>
+              <a:spcAft>
+                <a:spcPts val="200"/>
+              </a:spcAft>
+            </a:pPr>
+            <a:r>
+              <a:rPr sz="1300">
+                <a:solidFill>
+                  <a:srgbClr val="3D5466"/>
+                </a:solidFill>
+                <a:latin typeface="Arial"/>
+              </a:rPr>
+              <a:t>▸  Berater A will „bis Mittag" eine Engagementübersicht für einen spontanen Termin.</a:t>
+            </a:r>
+          </a:p>
+          <a:p>
+            <a:pPr marL="190500" indent="-190500">
+              <a:spcBef>
+                <a:spcPts val="400"/>
+              </a:spcBef>
+              <a:spcAft>
+                <a:spcPts val="200"/>
+              </a:spcAft>
+            </a:pPr>
+            <a:r>
+              <a:rPr sz="1300">
+                <a:solidFill>
+                  <a:srgbClr val="3D5466"/>
+                </a:solidFill>
+                <a:latin typeface="Arial"/>
+              </a:rPr>
+              <a:t>▸  Berater B hat gestern per Zuruf einen Auftrag gegeben, den Sie anders verstanden haben – jetzt ist er verärgert.</a:t>
+            </a:r>
+          </a:p>
+          <a:p>
+            <a:pPr marL="190500" indent="-190500">
+              <a:spcBef>
+                <a:spcPts val="400"/>
+              </a:spcBef>
+              <a:spcAft>
+                <a:spcPts val="200"/>
+              </a:spcAft>
+            </a:pPr>
+            <a:r>
+              <a:rPr sz="1300">
+                <a:solidFill>
+                  <a:srgbClr val="3D5466"/>
+                </a:solidFill>
+                <a:latin typeface="Arial"/>
+              </a:rPr>
+              <a:t>▸  Berater C bittet „wenn Zeit ist" um eine Datenpflege.</a:t>
+            </a:r>
+          </a:p>
+          <a:p>
+            <a:pPr>
+              <a:spcBef>
+                <a:spcPts val="1000"/>
+              </a:spcBef>
+              <a:spcAft>
+                <a:spcPts val="200"/>
+              </a:spcAft>
+            </a:pPr>
+            <a:r>
+              <a:rPr sz="800" b="1">
+                <a:solidFill>
+                  <a:srgbClr val="78808C"/>
+                </a:solidFill>
+                <a:latin typeface="Consolas"/>
+              </a:rPr>
+              <a:t>IHRE AUFGABE</a:t>
+            </a:r>
+          </a:p>
+          <a:p>
+            <a:pPr marL="190500" indent="-190500">
+              <a:spcBef>
+                <a:spcPts val="400"/>
+              </a:spcBef>
+              <a:spcAft>
+                <a:spcPts val="200"/>
+              </a:spcAft>
+            </a:pPr>
+            <a:r>
+              <a:rPr sz="1300">
+                <a:solidFill>
+                  <a:srgbClr val="3D5466"/>
+                </a:solidFill>
+                <a:latin typeface="Arial"/>
+              </a:rPr>
+              <a:t>▸  Identifizieren Sie zuerst die Ursache jeder Situation – dann entscheiden Sie.</a:t>
+            </a:r>
+          </a:p>
+        </p:txBody>
+      </p:sp>
+      <p:sp>
+        <p:nvSpPr>
+          <p:cNvPr id="9" name="Rectangle 8"/>
+          <p:cNvSpPr/>
+          <p:nvPr/>
+        </p:nvSpPr>
+        <p:spPr>
+          <a:xfrm>
+            <a:off x="0" y="6510528"/>
+            <a:ext cx="12188952" cy="347472"/>
+          </a:xfrm>
+          <a:prstGeom prst="rect">
+            <a:avLst/>
+          </a:prstGeom>
+          <a:solidFill>
+            <a:srgbClr val="0A1937"/>
+          </a:solidFill>
+          <a:ln>
+            <a:noFill/>
+          </a:ln>
+        </p:spPr>
+        <p:style>
+          <a:lnRef idx="1">
+            <a:schemeClr val="accent1"/>
+          </a:lnRef>
+          <a:fillRef idx="3">
+            <a:schemeClr val="accent1"/>
+          </a:fillRef>
+          <a:effectRef idx="2">
+            <a:schemeClr val="accent1"/>
+          </a:effectRef>
+          <a:fontRef idx="minor">
+            <a:schemeClr val="lt1"/>
+          </a:fontRef>
+        </p:style>
+        <p:txBody>
+          <a:bodyPr rtlCol="0" anchor="ctr"/>
+          <a:lstStyle/>
+          <a:p>
+            <a:pPr algn="ctr"/>
+          </a:p>
+        </p:txBody>
+      </p:sp>
+      <p:sp>
+        <p:nvSpPr>
+          <p:cNvPr id="10" name="TextBox 9"/>
+          <p:cNvSpPr txBox="1"/>
+          <p:nvPr/>
+        </p:nvSpPr>
+        <p:spPr>
+          <a:xfrm>
+            <a:off x="685800" y="6583680"/>
+            <a:ext cx="6490411" cy="256032"/>
+          </a:xfrm>
+          <a:prstGeom prst="rect">
+            <a:avLst/>
+          </a:prstGeom>
+          <a:noFill/>
+        </p:spPr>
+        <p:txBody>
+          <a:bodyPr wrap="none">
+            <a:spAutoFit/>
+          </a:bodyPr>
+          <a:lstStyle/>
+          <a:p>
+            <a:pPr algn="l"/>
+            <a:r>
+              <a:rPr sz="700">
+                <a:solidFill>
+                  <a:srgbClr val="A0B4D2"/>
+                </a:solidFill>
+                <a:latin typeface="Consolas"/>
+              </a:rPr>
+              <a:t>FKB Campus  ·  VA07</a:t>
+            </a:r>
+          </a:p>
+        </p:txBody>
+      </p:sp>
+    </p:spTree>
+  </p:cSld>
+  <p:clrMapOvr>
+    <a:masterClrMapping/>
+  </p:clrMapOvr>
+</p:sld>
+</file>
+
+<file path=ppt/slides/slide13.xml><?xml version="1.0" encoding="utf-8"?>
+<p:sld xmlns:a="http://schemas.openxmlformats.org/drawingml/2006/main" xmlns:p="http://schemas.openxmlformats.org/presentationml/2006/main" xmlns:r="http://schemas.openxmlformats.org/officeDocument/2006/relationships">
+  <p:cSld>
+    <p:spTree>
+      <p:nvGrpSpPr>
+        <p:cNvPr id="1" name=""/>
+        <p:cNvGrpSpPr/>
+        <p:nvPr/>
+      </p:nvGrpSpPr>
+      <p:grpSpPr/>
+      <p:sp>
+        <p:nvSpPr>
+          <p:cNvPr id="2" name="Rectangle 1"/>
+          <p:cNvSpPr/>
+          <p:nvPr/>
+        </p:nvSpPr>
+        <p:spPr>
+          <a:xfrm>
+            <a:off x="0" y="0"/>
+            <a:ext cx="12188952" cy="6858000"/>
+          </a:xfrm>
+          <a:prstGeom prst="rect">
+            <a:avLst/>
+          </a:prstGeom>
+          <a:solidFill>
+            <a:srgbClr val="EDEDF3"/>
+          </a:solidFill>
+          <a:ln>
+            <a:noFill/>
+          </a:ln>
+        </p:spPr>
+        <p:style>
+          <a:lnRef idx="1">
+            <a:schemeClr val="accent1"/>
+          </a:lnRef>
+          <a:fillRef idx="3">
+            <a:schemeClr val="accent1"/>
+          </a:fillRef>
+          <a:effectRef idx="2">
+            <a:schemeClr val="accent1"/>
+          </a:effectRef>
+          <a:fontRef idx="minor">
+            <a:schemeClr val="lt1"/>
+          </a:fontRef>
+        </p:style>
+        <p:txBody>
+          <a:bodyPr rtlCol="0" anchor="ctr"/>
+          <a:lstStyle/>
+          <a:p>
+            <a:pPr algn="ctr"/>
+          </a:p>
+        </p:txBody>
+      </p:sp>
+      <p:sp>
+        <p:nvSpPr>
+          <p:cNvPr id="3" name="Rectangle 2"/>
+          <p:cNvSpPr/>
+          <p:nvPr/>
+        </p:nvSpPr>
+        <p:spPr>
+          <a:xfrm>
+            <a:off x="0" y="0"/>
+            <a:ext cx="12188952" cy="50292"/>
+          </a:xfrm>
+          <a:prstGeom prst="rect">
+            <a:avLst/>
+          </a:prstGeom>
+          <a:solidFill>
+            <a:srgbClr val="1F2C56"/>
+          </a:solidFill>
+          <a:ln>
+            <a:noFill/>
+          </a:ln>
+        </p:spPr>
+        <p:style>
+          <a:lnRef idx="1">
+            <a:schemeClr val="accent1"/>
+          </a:lnRef>
+          <a:fillRef idx="3">
+            <a:schemeClr val="accent1"/>
+          </a:fillRef>
+          <a:effectRef idx="2">
+            <a:schemeClr val="accent1"/>
+          </a:effectRef>
+          <a:fontRef idx="minor">
+            <a:schemeClr val="lt1"/>
+          </a:fontRef>
+        </p:style>
+        <p:txBody>
+          <a:bodyPr rtlCol="0" anchor="ctr"/>
+          <a:lstStyle/>
+          <a:p>
+            <a:pPr algn="ctr"/>
+          </a:p>
+        </p:txBody>
+      </p:sp>
+      <p:sp>
+        <p:nvSpPr>
+          <p:cNvPr id="4" name="TextBox 3"/>
+          <p:cNvSpPr txBox="1"/>
+          <p:nvPr/>
+        </p:nvSpPr>
+        <p:spPr>
+          <a:xfrm>
+            <a:off x="685800" y="109728"/>
+            <a:ext cx="10817352" cy="228600"/>
+          </a:xfrm>
+          <a:prstGeom prst="rect">
+            <a:avLst/>
+          </a:prstGeom>
+          <a:noFill/>
+        </p:spPr>
+        <p:txBody>
+          <a:bodyPr wrap="none">
+            <a:spAutoFit/>
+          </a:bodyPr>
+          <a:lstStyle/>
+          <a:p>
+            <a:pPr algn="l"/>
+            <a:r>
+              <a:rPr sz="750">
+                <a:solidFill>
+                  <a:srgbClr val="78808C"/>
+                </a:solidFill>
+                <a:latin typeface="Consolas"/>
+              </a:rPr>
+              <a:t>VA07  ·  INHALT</a:t>
+            </a:r>
+          </a:p>
+        </p:txBody>
+      </p:sp>
+      <p:sp>
+        <p:nvSpPr>
+          <p:cNvPr id="5" name="Rectangle 4"/>
+          <p:cNvSpPr/>
+          <p:nvPr/>
+        </p:nvSpPr>
+        <p:spPr>
+          <a:xfrm>
+            <a:off x="0" y="1234440"/>
+            <a:ext cx="12188952" cy="12700"/>
+          </a:xfrm>
+          <a:prstGeom prst="rect">
+            <a:avLst/>
+          </a:prstGeom>
+          <a:solidFill>
+            <a:srgbClr val="D8DFE4"/>
+          </a:solidFill>
+          <a:ln>
+            <a:noFill/>
+          </a:ln>
+        </p:spPr>
+        <p:style>
+          <a:lnRef idx="1">
+            <a:schemeClr val="accent1"/>
+          </a:lnRef>
+          <a:fillRef idx="3">
+            <a:schemeClr val="accent1"/>
+          </a:fillRef>
+          <a:effectRef idx="2">
+            <a:schemeClr val="accent1"/>
+          </a:effectRef>
+          <a:fontRef idx="minor">
+            <a:schemeClr val="lt1"/>
+          </a:fontRef>
+        </p:style>
+        <p:txBody>
+          <a:bodyPr rtlCol="0" anchor="ctr"/>
+          <a:lstStyle/>
+          <a:p>
+            <a:pPr algn="ctr"/>
+          </a:p>
+        </p:txBody>
+      </p:sp>
+      <p:sp>
+        <p:nvSpPr>
+          <p:cNvPr id="6" name="Rectangle 5"/>
+          <p:cNvSpPr/>
+          <p:nvPr/>
+        </p:nvSpPr>
+        <p:spPr>
+          <a:xfrm>
+            <a:off x="685800" y="502920"/>
+            <a:ext cx="36576" cy="658368"/>
+          </a:xfrm>
+          <a:prstGeom prst="rect">
+            <a:avLst/>
+          </a:prstGeom>
+          <a:solidFill>
+            <a:srgbClr val="D9C089"/>
+          </a:solidFill>
+          <a:ln>
+            <a:noFill/>
+          </a:ln>
+        </p:spPr>
+        <p:style>
+          <a:lnRef idx="1">
+            <a:schemeClr val="accent1"/>
+          </a:lnRef>
+          <a:fillRef idx="3">
+            <a:schemeClr val="accent1"/>
+          </a:fillRef>
+          <a:effectRef idx="2">
+            <a:schemeClr val="accent1"/>
+          </a:effectRef>
+          <a:fontRef idx="minor">
+            <a:schemeClr val="lt1"/>
+          </a:fontRef>
+        </p:style>
+        <p:txBody>
+          <a:bodyPr rtlCol="0" anchor="ctr"/>
+          <a:lstStyle/>
+          <a:p>
+            <a:pPr algn="ctr"/>
+          </a:p>
+        </p:txBody>
+      </p:sp>
+      <p:sp>
+        <p:nvSpPr>
+          <p:cNvPr id="7" name="TextBox 6"/>
+          <p:cNvSpPr txBox="1"/>
+          <p:nvPr/>
+        </p:nvSpPr>
+        <p:spPr>
+          <a:xfrm>
+            <a:off x="813816" y="502920"/>
+            <a:ext cx="10634472" cy="685800"/>
+          </a:xfrm>
+          <a:prstGeom prst="rect">
+            <a:avLst/>
+          </a:prstGeom>
+          <a:noFill/>
+        </p:spPr>
+        <p:txBody>
+          <a:bodyPr wrap="square">
+            <a:spAutoFit/>
+          </a:bodyPr>
+          <a:lstStyle/>
+          <a:p>
+            <a:pPr algn="l"/>
+            <a:r>
+              <a:rPr sz="2400" b="1" i="0">
+                <a:solidFill>
+                  <a:srgbClr val="1F2C56"/>
+                </a:solidFill>
+                <a:latin typeface="Arial"/>
+              </a:rPr>
+              <a:t>Handlungsempfehlung: Regel schlägt Lautstärke</a:t>
+            </a:r>
+          </a:p>
+        </p:txBody>
+      </p:sp>
+      <p:sp>
+        <p:nvSpPr>
+          <p:cNvPr id="8" name="TextBox 7"/>
+          <p:cNvSpPr txBox="1"/>
+          <p:nvPr/>
+        </p:nvSpPr>
+        <p:spPr>
+          <a:xfrm>
+            <a:off x="685800" y="1417320"/>
+            <a:ext cx="10817352" cy="4892040"/>
+          </a:xfrm>
+          <a:prstGeom prst="rect">
+            <a:avLst/>
+          </a:prstGeom>
+          <a:noFill/>
+        </p:spPr>
+        <p:txBody>
+          <a:bodyPr wrap="square" anchor="ctr">
+            <a:spAutoFit/>
+          </a:bodyPr>
+          <a:lstStyle/>
+          <a:p>
+            <a:pPr marL="177800" indent="-177800">
+              <a:spcBef>
+                <a:spcPts val="600"/>
+              </a:spcBef>
+              <a:spcAft>
+                <a:spcPts val="200"/>
+              </a:spcAft>
+            </a:pPr>
+            <a:r>
+              <a:rPr sz="1200" i="1">
+                <a:solidFill>
+                  <a:srgbClr val="3D5466"/>
+                </a:solidFill>
+                <a:latin typeface="Arial"/>
+              </a:rPr>
+              <a:t>→  Wenn mehrere Berater gleichzeitig „dringend" melden — dann nach vereinbarter Priorisierungsregel entscheiden und transparent zurückmelden.</a:t>
+            </a:r>
+          </a:p>
+          <a:p>
+            <a:pPr marL="177800" indent="-177800">
+              <a:spcBef>
+                <a:spcPts val="600"/>
+              </a:spcBef>
+              <a:spcAft>
+                <a:spcPts val="200"/>
+              </a:spcAft>
+            </a:pPr>
+            <a:r>
+              <a:rPr sz="1200" i="1">
+                <a:solidFill>
+                  <a:srgbClr val="3D5466"/>
+                </a:solidFill>
+                <a:latin typeface="Arial"/>
+              </a:rPr>
+              <a:t>→  Wenn ein Auftrag per Zuruf kommt — dann ihn kurz im System festhalten und das Verständnis rückbestätigen.</a:t>
+            </a:r>
+          </a:p>
+          <a:p>
+            <a:pPr marL="177800" indent="-177800">
+              <a:spcBef>
+                <a:spcPts val="600"/>
+              </a:spcBef>
+              <a:spcAft>
+                <a:spcPts val="200"/>
+              </a:spcAft>
+            </a:pPr>
+            <a:r>
+              <a:rPr sz="1200" i="1">
+                <a:solidFill>
+                  <a:srgbClr val="3D5466"/>
+                </a:solidFill>
+                <a:latin typeface="Arial"/>
+              </a:rPr>
+              <a:t>→  Wenn Sie eine Zusage nicht halten können — dann früh und proaktiv einen realistischen Zeitpunkt nennen, statt es auflaufen zu lassen.</a:t>
+            </a:r>
+          </a:p>
+        </p:txBody>
+      </p:sp>
+      <p:sp>
+        <p:nvSpPr>
+          <p:cNvPr id="9" name="Rectangle 8"/>
+          <p:cNvSpPr/>
+          <p:nvPr/>
+        </p:nvSpPr>
+        <p:spPr>
+          <a:xfrm>
+            <a:off x="0" y="6510528"/>
+            <a:ext cx="12188952" cy="347472"/>
+          </a:xfrm>
+          <a:prstGeom prst="rect">
+            <a:avLst/>
+          </a:prstGeom>
+          <a:solidFill>
+            <a:srgbClr val="0A1937"/>
+          </a:solidFill>
+          <a:ln>
+            <a:noFill/>
+          </a:ln>
+        </p:spPr>
+        <p:style>
+          <a:lnRef idx="1">
+            <a:schemeClr val="accent1"/>
+          </a:lnRef>
+          <a:fillRef idx="3">
+            <a:schemeClr val="accent1"/>
+          </a:fillRef>
+          <a:effectRef idx="2">
+            <a:schemeClr val="accent1"/>
+          </a:effectRef>
+          <a:fontRef idx="minor">
+            <a:schemeClr val="lt1"/>
+          </a:fontRef>
+        </p:style>
+        <p:txBody>
+          <a:bodyPr rtlCol="0" anchor="ctr"/>
+          <a:lstStyle/>
+          <a:p>
+            <a:pPr algn="ctr"/>
+          </a:p>
+        </p:txBody>
+      </p:sp>
+      <p:sp>
+        <p:nvSpPr>
+          <p:cNvPr id="10" name="TextBox 9"/>
+          <p:cNvSpPr txBox="1"/>
+          <p:nvPr/>
+        </p:nvSpPr>
+        <p:spPr>
+          <a:xfrm>
+            <a:off x="685800" y="6583680"/>
+            <a:ext cx="6490411" cy="256032"/>
+          </a:xfrm>
+          <a:prstGeom prst="rect">
+            <a:avLst/>
+          </a:prstGeom>
+          <a:noFill/>
+        </p:spPr>
+        <p:txBody>
+          <a:bodyPr wrap="none">
+            <a:spAutoFit/>
+          </a:bodyPr>
+          <a:lstStyle/>
+          <a:p>
+            <a:pPr algn="l"/>
+            <a:r>
+              <a:rPr sz="700">
+                <a:solidFill>
+                  <a:srgbClr val="A0B4D2"/>
+                </a:solidFill>
+                <a:latin typeface="Consolas"/>
+              </a:rPr>
+              <a:t>FKB Campus  ·  VA07</a:t>
+            </a:r>
+          </a:p>
+        </p:txBody>
+      </p:sp>
+    </p:spTree>
+  </p:cSld>
+  <p:clrMapOvr>
+    <a:masterClrMapping/>
+  </p:clrMapOvr>
+</p:sld>
+</file>
+
+<file path=ppt/slides/slide14.xml><?xml version="1.0" encoding="utf-8"?>
+<p:sld xmlns:a="http://schemas.openxmlformats.org/drawingml/2006/main" xmlns:p="http://schemas.openxmlformats.org/presentationml/2006/main" xmlns:r="http://schemas.openxmlformats.org/officeDocument/2006/relationships">
+  <p:cSld>
+    <p:spTree>
+      <p:nvGrpSpPr>
+        <p:cNvPr id="1" name=""/>
+        <p:cNvGrpSpPr/>
+        <p:nvPr/>
+      </p:nvGrpSpPr>
+      <p:grpSpPr/>
+      <p:sp>
+        <p:nvSpPr>
+          <p:cNvPr id="2" name="Rectangle 1"/>
+          <p:cNvSpPr/>
+          <p:nvPr/>
+        </p:nvSpPr>
+        <p:spPr>
+          <a:xfrm>
+            <a:off x="0" y="0"/>
+            <a:ext cx="12188952" cy="6858000"/>
+          </a:xfrm>
+          <a:prstGeom prst="rect">
+            <a:avLst/>
+          </a:prstGeom>
+          <a:solidFill>
+            <a:srgbClr val="EDEDF3"/>
+          </a:solidFill>
+          <a:ln>
+            <a:noFill/>
+          </a:ln>
+        </p:spPr>
+        <p:style>
+          <a:lnRef idx="1">
+            <a:schemeClr val="accent1"/>
+          </a:lnRef>
+          <a:fillRef idx="3">
+            <a:schemeClr val="accent1"/>
+          </a:fillRef>
+          <a:effectRef idx="2">
+            <a:schemeClr val="accent1"/>
+          </a:effectRef>
+          <a:fontRef idx="minor">
+            <a:schemeClr val="lt1"/>
+          </a:fontRef>
+        </p:style>
+        <p:txBody>
+          <a:bodyPr rtlCol="0" anchor="ctr"/>
+          <a:lstStyle/>
+          <a:p>
+            <a:pPr algn="ctr"/>
+          </a:p>
+        </p:txBody>
+      </p:sp>
+      <p:sp>
+        <p:nvSpPr>
+          <p:cNvPr id="3" name="Rectangle 2"/>
+          <p:cNvSpPr/>
+          <p:nvPr/>
+        </p:nvSpPr>
+        <p:spPr>
+          <a:xfrm>
+            <a:off x="0" y="0"/>
+            <a:ext cx="12188952" cy="50292"/>
+          </a:xfrm>
+          <a:prstGeom prst="rect">
+            <a:avLst/>
+          </a:prstGeom>
+          <a:solidFill>
+            <a:srgbClr val="1F2C56"/>
+          </a:solidFill>
+          <a:ln>
+            <a:noFill/>
+          </a:ln>
+        </p:spPr>
+        <p:style>
+          <a:lnRef idx="1">
+            <a:schemeClr val="accent1"/>
+          </a:lnRef>
+          <a:fillRef idx="3">
+            <a:schemeClr val="accent1"/>
+          </a:fillRef>
+          <a:effectRef idx="2">
+            <a:schemeClr val="accent1"/>
+          </a:effectRef>
+          <a:fontRef idx="minor">
+            <a:schemeClr val="lt1"/>
+          </a:fontRef>
+        </p:style>
+        <p:txBody>
+          <a:bodyPr rtlCol="0" anchor="ctr"/>
+          <a:lstStyle/>
+          <a:p>
+            <a:pPr algn="ctr"/>
+          </a:p>
+        </p:txBody>
+      </p:sp>
+      <p:sp>
+        <p:nvSpPr>
+          <p:cNvPr id="4" name="TextBox 3"/>
+          <p:cNvSpPr txBox="1"/>
+          <p:nvPr/>
+        </p:nvSpPr>
+        <p:spPr>
+          <a:xfrm>
+            <a:off x="685800" y="109728"/>
+            <a:ext cx="10817352" cy="228600"/>
+          </a:xfrm>
+          <a:prstGeom prst="rect">
+            <a:avLst/>
+          </a:prstGeom>
+          <a:noFill/>
+        </p:spPr>
+        <p:txBody>
+          <a:bodyPr wrap="none">
+            <a:spAutoFit/>
+          </a:bodyPr>
+          <a:lstStyle/>
+          <a:p>
+            <a:pPr algn="l"/>
+            <a:r>
+              <a:rPr sz="750">
+                <a:solidFill>
+                  <a:srgbClr val="78808C"/>
+                </a:solidFill>
+                <a:latin typeface="Consolas"/>
+              </a:rPr>
+              <a:t>VA07  ·  ARBEITSBLATT</a:t>
+            </a:r>
+          </a:p>
+        </p:txBody>
+      </p:sp>
+      <p:sp>
+        <p:nvSpPr>
+          <p:cNvPr id="5" name="Rectangle 4"/>
+          <p:cNvSpPr/>
+          <p:nvPr/>
+        </p:nvSpPr>
+        <p:spPr>
+          <a:xfrm>
+            <a:off x="0" y="1234440"/>
+            <a:ext cx="12188952" cy="12700"/>
+          </a:xfrm>
+          <a:prstGeom prst="rect">
+            <a:avLst/>
+          </a:prstGeom>
+          <a:solidFill>
+            <a:srgbClr val="D8DFE4"/>
+          </a:solidFill>
+          <a:ln>
+            <a:noFill/>
+          </a:ln>
+        </p:spPr>
+        <p:style>
+          <a:lnRef idx="1">
+            <a:schemeClr val="accent1"/>
+          </a:lnRef>
+          <a:fillRef idx="3">
+            <a:schemeClr val="accent1"/>
+          </a:fillRef>
+          <a:effectRef idx="2">
+            <a:schemeClr val="accent1"/>
+          </a:effectRef>
+          <a:fontRef idx="minor">
+            <a:schemeClr val="lt1"/>
+          </a:fontRef>
+        </p:style>
+        <p:txBody>
+          <a:bodyPr rtlCol="0" anchor="ctr"/>
+          <a:lstStyle/>
+          <a:p>
+            <a:pPr algn="ctr"/>
+          </a:p>
+        </p:txBody>
+      </p:sp>
+      <p:sp>
+        <p:nvSpPr>
+          <p:cNvPr id="6" name="Rectangle 5"/>
+          <p:cNvSpPr/>
+          <p:nvPr/>
+        </p:nvSpPr>
+        <p:spPr>
+          <a:xfrm>
+            <a:off x="685800" y="502920"/>
+            <a:ext cx="36576" cy="658368"/>
+          </a:xfrm>
+          <a:prstGeom prst="rect">
+            <a:avLst/>
+          </a:prstGeom>
+          <a:solidFill>
+            <a:srgbClr val="D9C089"/>
+          </a:solidFill>
+          <a:ln>
+            <a:noFill/>
+          </a:ln>
+        </p:spPr>
+        <p:style>
+          <a:lnRef idx="1">
+            <a:schemeClr val="accent1"/>
+          </a:lnRef>
+          <a:fillRef idx="3">
+            <a:schemeClr val="accent1"/>
+          </a:fillRef>
+          <a:effectRef idx="2">
+            <a:schemeClr val="accent1"/>
+          </a:effectRef>
+          <a:fontRef idx="minor">
+            <a:schemeClr val="lt1"/>
+          </a:fontRef>
+        </p:style>
+        <p:txBody>
+          <a:bodyPr rtlCol="0" anchor="ctr"/>
+          <a:lstStyle/>
+          <a:p>
+            <a:pPr algn="ctr"/>
+          </a:p>
+        </p:txBody>
+      </p:sp>
+      <p:sp>
+        <p:nvSpPr>
+          <p:cNvPr id="7" name="TextBox 6"/>
+          <p:cNvSpPr txBox="1"/>
+          <p:nvPr/>
+        </p:nvSpPr>
+        <p:spPr>
+          <a:xfrm>
+            <a:off x="813816" y="502920"/>
+            <a:ext cx="10634472" cy="685800"/>
+          </a:xfrm>
+          <a:prstGeom prst="rect">
+            <a:avLst/>
+          </a:prstGeom>
+          <a:noFill/>
+        </p:spPr>
+        <p:txBody>
+          <a:bodyPr wrap="square">
+            <a:spAutoFit/>
+          </a:bodyPr>
+          <a:lstStyle/>
+          <a:p>
+            <a:pPr algn="l"/>
+            <a:r>
+              <a:rPr sz="2400" b="1" i="0">
+                <a:solidFill>
+                  <a:srgbClr val="1F2C56"/>
+                </a:solidFill>
+                <a:latin typeface="Arial"/>
+              </a:rPr>
+              <a:t>Praxisfall bearbeiten: Rollen klären, Konflikte lösen</a:t>
+            </a:r>
+          </a:p>
+        </p:txBody>
+      </p:sp>
+      <p:sp>
+        <p:nvSpPr>
+          <p:cNvPr id="8" name="TextBox 7"/>
+          <p:cNvSpPr txBox="1"/>
+          <p:nvPr/>
+        </p:nvSpPr>
+        <p:spPr>
+          <a:xfrm>
+            <a:off x="685800" y="1554480"/>
+            <a:ext cx="10817352" cy="3840480"/>
+          </a:xfrm>
+          <a:prstGeom prst="rect">
+            <a:avLst/>
+          </a:prstGeom>
+          <a:noFill/>
+        </p:spPr>
+        <p:txBody>
+          <a:bodyPr wrap="square">
+            <a:spAutoFit/>
+          </a:bodyPr>
+          <a:lstStyle/>
+          <a:p>
+            <a:pPr marL="190500" indent="-190500">
+              <a:spcBef>
+                <a:spcPts val="400"/>
+              </a:spcBef>
+              <a:spcAft>
+                <a:spcPts val="200"/>
+              </a:spcAft>
+            </a:pPr>
+            <a:r>
+              <a:rPr sz="1400">
+                <a:solidFill>
+                  <a:srgbClr val="3D5466"/>
+                </a:solidFill>
+                <a:latin typeface="Arial"/>
+              </a:rPr>
+              <a:t>▸  Reflektieren Sie Ihre eigenen Rollen und die Erwartungen an Sie (AB-1).</a:t>
+            </a:r>
+          </a:p>
+          <a:p>
+            <a:pPr marL="190500" indent="-190500">
+              <a:spcBef>
+                <a:spcPts val="400"/>
+              </a:spcBef>
+              <a:spcAft>
+                <a:spcPts val="200"/>
+              </a:spcAft>
+            </a:pPr>
+            <a:r>
+              <a:rPr sz="1400">
+                <a:solidFill>
+                  <a:srgbClr val="3D5466"/>
+                </a:solidFill>
+                <a:latin typeface="Arial"/>
+              </a:rPr>
+              <a:t>▸  Ordnen Sie die drei Vormittags-Situationen ihrer Ursache zu: Zuständigkeit, Information oder Priorität (AB-2).</a:t>
+            </a:r>
+          </a:p>
+          <a:p>
+            <a:pPr marL="190500" indent="-190500">
+              <a:spcBef>
+                <a:spcPts val="400"/>
+              </a:spcBef>
+              <a:spcAft>
+                <a:spcPts val="200"/>
+              </a:spcAft>
+            </a:pPr>
+            <a:r>
+              <a:rPr sz="1400">
+                <a:solidFill>
+                  <a:srgbClr val="3D5466"/>
+                </a:solidFill>
+                <a:latin typeface="Arial"/>
+              </a:rPr>
+              <a:t>▸  Formulieren Sie Übergaberegeln – inklusive Einholung der Zustimmung (AB-3).</a:t>
+            </a:r>
+          </a:p>
+          <a:p>
+            <a:pPr marL="190500" indent="-190500">
+              <a:spcBef>
+                <a:spcPts val="400"/>
+              </a:spcBef>
+              <a:spcAft>
+                <a:spcPts val="200"/>
+              </a:spcAft>
+            </a:pPr>
+            <a:r>
+              <a:rPr sz="1400">
+                <a:solidFill>
+                  <a:srgbClr val="3D5466"/>
+                </a:solidFill>
+                <a:latin typeface="Arial"/>
+              </a:rPr>
+              <a:t>▸  Üben Sie im Rollenspiel: priorisieren, zurückmelden, ansprechen (AB-4) – Karte AB-5 als Werkzeug.</a:t>
+            </a:r>
+          </a:p>
+        </p:txBody>
+      </p:sp>
+      <p:sp>
+        <p:nvSpPr>
+          <p:cNvPr id="9" name="Rectangle 8"/>
+          <p:cNvSpPr/>
+          <p:nvPr/>
+        </p:nvSpPr>
+        <p:spPr>
+          <a:xfrm>
+            <a:off x="685800" y="5486400"/>
+            <a:ext cx="10817352" cy="640080"/>
+          </a:xfrm>
+          <a:prstGeom prst="rect">
+            <a:avLst/>
+          </a:prstGeom>
+          <a:solidFill>
+            <a:srgbClr val="1F2C56"/>
+          </a:solidFill>
+          <a:ln>
+            <a:noFill/>
+          </a:ln>
+        </p:spPr>
+        <p:style>
+          <a:lnRef idx="1">
+            <a:schemeClr val="accent1"/>
+          </a:lnRef>
+          <a:fillRef idx="3">
+            <a:schemeClr val="accent1"/>
+          </a:fillRef>
+          <a:effectRef idx="2">
+            <a:schemeClr val="accent1"/>
+          </a:effectRef>
+          <a:fontRef idx="minor">
+            <a:schemeClr val="lt1"/>
+          </a:fontRef>
+        </p:style>
+        <p:txBody>
+          <a:bodyPr rtlCol="0" anchor="ctr"/>
+          <a:lstStyle/>
+          <a:p>
+            <a:pPr algn="ctr"/>
+          </a:p>
+        </p:txBody>
+      </p:sp>
+      <p:sp>
+        <p:nvSpPr>
+          <p:cNvPr id="10" name="TextBox 9"/>
+          <p:cNvSpPr txBox="1"/>
+          <p:nvPr/>
+        </p:nvSpPr>
+        <p:spPr>
+          <a:xfrm>
+            <a:off x="868680" y="5596128"/>
+            <a:ext cx="10451592" cy="457200"/>
+          </a:xfrm>
+          <a:prstGeom prst="rect">
+            <a:avLst/>
+          </a:prstGeom>
+          <a:noFill/>
+        </p:spPr>
+        <p:txBody>
+          <a:bodyPr wrap="square">
+            <a:spAutoFit/>
+          </a:bodyPr>
+          <a:lstStyle/>
+          <a:p>
+            <a:pPr algn="l"/>
+            <a:r>
+              <a:rPr sz="1300" b="1" i="0">
+                <a:solidFill>
+                  <a:srgbClr val="FFFFFF"/>
+                </a:solidFill>
+                <a:latin typeface="Arial"/>
+              </a:rPr>
+              <a:t>→  Bearbeitung im Teilnehmer-Workbook (Arbeitsblatt mit Ausfüllfeldern)</a:t>
+            </a:r>
+          </a:p>
+        </p:txBody>
+      </p:sp>
+      <p:sp>
+        <p:nvSpPr>
+          <p:cNvPr id="11" name="Rectangle 10"/>
+          <p:cNvSpPr/>
+          <p:nvPr/>
+        </p:nvSpPr>
+        <p:spPr>
+          <a:xfrm>
+            <a:off x="0" y="6510528"/>
+            <a:ext cx="12188952" cy="347472"/>
+          </a:xfrm>
+          <a:prstGeom prst="rect">
+            <a:avLst/>
+          </a:prstGeom>
+          <a:solidFill>
+            <a:srgbClr val="0A1937"/>
+          </a:solidFill>
+          <a:ln>
+            <a:noFill/>
+          </a:ln>
+        </p:spPr>
+        <p:style>
+          <a:lnRef idx="1">
+            <a:schemeClr val="accent1"/>
+          </a:lnRef>
+          <a:fillRef idx="3">
+            <a:schemeClr val="accent1"/>
+          </a:fillRef>
+          <a:effectRef idx="2">
+            <a:schemeClr val="accent1"/>
+          </a:effectRef>
+          <a:fontRef idx="minor">
+            <a:schemeClr val="lt1"/>
+          </a:fontRef>
+        </p:style>
+        <p:txBody>
+          <a:bodyPr rtlCol="0" anchor="ctr"/>
+          <a:lstStyle/>
+          <a:p>
+            <a:pPr algn="ctr"/>
+          </a:p>
+        </p:txBody>
+      </p:sp>
+      <p:sp>
+        <p:nvSpPr>
+          <p:cNvPr id="12" name="TextBox 11"/>
+          <p:cNvSpPr txBox="1"/>
+          <p:nvPr/>
+        </p:nvSpPr>
+        <p:spPr>
+          <a:xfrm>
+            <a:off x="685800" y="6583680"/>
+            <a:ext cx="6490411" cy="256032"/>
+          </a:xfrm>
+          <a:prstGeom prst="rect">
+            <a:avLst/>
+          </a:prstGeom>
+          <a:noFill/>
+        </p:spPr>
+        <p:txBody>
+          <a:bodyPr wrap="none">
+            <a:spAutoFit/>
+          </a:bodyPr>
+          <a:lstStyle/>
+          <a:p>
+            <a:pPr algn="l"/>
+            <a:r>
+              <a:rPr sz="700">
+                <a:solidFill>
+                  <a:srgbClr val="A0B4D2"/>
+                </a:solidFill>
+                <a:latin typeface="Consolas"/>
+              </a:rPr>
+              <a:t>FKB Campus  ·  VA07</a:t>
+            </a:r>
+          </a:p>
+        </p:txBody>
+      </p:sp>
+    </p:spTree>
+  </p:cSld>
+  <p:clrMapOvr>
+    <a:masterClrMapping/>
+  </p:clrMapOvr>
+</p:sld>
+</file>
+
+<file path=ppt/slides/slide15.xml><?xml version="1.0" encoding="utf-8"?>
+<p:sld xmlns:a="http://schemas.openxmlformats.org/drawingml/2006/main" xmlns:p="http://schemas.openxmlformats.org/presentationml/2006/main" xmlns:r="http://schemas.openxmlformats.org/officeDocument/2006/relationships">
+  <p:cSld>
+    <p:spTree>
+      <p:nvGrpSpPr>
+        <p:cNvPr id="1" name=""/>
+        <p:cNvGrpSpPr/>
+        <p:nvPr/>
+      </p:nvGrpSpPr>
+      <p:grpSpPr/>
+      <p:sp>
+        <p:nvSpPr>
+          <p:cNvPr id="2" name="Rectangle 1"/>
+          <p:cNvSpPr/>
+          <p:nvPr/>
+        </p:nvSpPr>
+        <p:spPr>
+          <a:xfrm>
+            <a:off x="0" y="0"/>
+            <a:ext cx="12188952" cy="6858000"/>
+          </a:xfrm>
+          <a:prstGeom prst="rect">
+            <a:avLst/>
+          </a:prstGeom>
+          <a:solidFill>
+            <a:srgbClr val="EDEDF3"/>
+          </a:solidFill>
+          <a:ln>
+            <a:noFill/>
+          </a:ln>
+        </p:spPr>
+        <p:style>
+          <a:lnRef idx="1">
+            <a:schemeClr val="accent1"/>
+          </a:lnRef>
+          <a:fillRef idx="3">
+            <a:schemeClr val="accent1"/>
+          </a:fillRef>
+          <a:effectRef idx="2">
+            <a:schemeClr val="accent1"/>
+          </a:effectRef>
+          <a:fontRef idx="minor">
+            <a:schemeClr val="lt1"/>
+          </a:fontRef>
+        </p:style>
+        <p:txBody>
+          <a:bodyPr rtlCol="0" anchor="ctr"/>
+          <a:lstStyle/>
+          <a:p>
+            <a:pPr algn="ctr"/>
+          </a:p>
+        </p:txBody>
+      </p:sp>
+      <p:sp>
+        <p:nvSpPr>
+          <p:cNvPr id="3" name="Rectangle 2"/>
+          <p:cNvSpPr/>
+          <p:nvPr/>
+        </p:nvSpPr>
+        <p:spPr>
+          <a:xfrm>
+            <a:off x="0" y="0"/>
+            <a:ext cx="12188952" cy="50292"/>
+          </a:xfrm>
+          <a:prstGeom prst="rect">
+            <a:avLst/>
+          </a:prstGeom>
+          <a:solidFill>
+            <a:srgbClr val="1F2C56"/>
+          </a:solidFill>
+          <a:ln>
+            <a:noFill/>
+          </a:ln>
+        </p:spPr>
+        <p:style>
+          <a:lnRef idx="1">
+            <a:schemeClr val="accent1"/>
+          </a:lnRef>
+          <a:fillRef idx="3">
+            <a:schemeClr val="accent1"/>
+          </a:fillRef>
+          <a:effectRef idx="2">
+            <a:schemeClr val="accent1"/>
+          </a:effectRef>
+          <a:fontRef idx="minor">
+            <a:schemeClr val="lt1"/>
+          </a:fontRef>
+        </p:style>
+        <p:txBody>
+          <a:bodyPr rtlCol="0" anchor="ctr"/>
+          <a:lstStyle/>
+          <a:p>
+            <a:pPr algn="ctr"/>
+          </a:p>
+        </p:txBody>
+      </p:sp>
+      <p:sp>
+        <p:nvSpPr>
+          <p:cNvPr id="4" name="TextBox 3"/>
+          <p:cNvSpPr txBox="1"/>
+          <p:nvPr/>
+        </p:nvSpPr>
+        <p:spPr>
+          <a:xfrm>
+            <a:off x="685800" y="109728"/>
+            <a:ext cx="10817352" cy="228600"/>
+          </a:xfrm>
+          <a:prstGeom prst="rect">
+            <a:avLst/>
+          </a:prstGeom>
+          <a:noFill/>
+        </p:spPr>
+        <p:txBody>
+          <a:bodyPr wrap="none">
+            <a:spAutoFit/>
+          </a:bodyPr>
+          <a:lstStyle/>
+          <a:p>
+            <a:pPr algn="l"/>
+            <a:r>
+              <a:rPr sz="750">
+                <a:solidFill>
+                  <a:srgbClr val="78808C"/>
+                </a:solidFill>
+                <a:latin typeface="Consolas"/>
+              </a:rPr>
+              <a:t>VA07  ·  INHALT</a:t>
+            </a:r>
+          </a:p>
+        </p:txBody>
+      </p:sp>
+      <p:sp>
+        <p:nvSpPr>
+          <p:cNvPr id="5" name="Rectangle 4"/>
+          <p:cNvSpPr/>
+          <p:nvPr/>
+        </p:nvSpPr>
+        <p:spPr>
+          <a:xfrm>
+            <a:off x="0" y="1234440"/>
+            <a:ext cx="12188952" cy="12700"/>
+          </a:xfrm>
+          <a:prstGeom prst="rect">
+            <a:avLst/>
+          </a:prstGeom>
+          <a:solidFill>
+            <a:srgbClr val="D8DFE4"/>
+          </a:solidFill>
+          <a:ln>
+            <a:noFill/>
+          </a:ln>
+        </p:spPr>
+        <p:style>
+          <a:lnRef idx="1">
+            <a:schemeClr val="accent1"/>
+          </a:lnRef>
+          <a:fillRef idx="3">
+            <a:schemeClr val="accent1"/>
+          </a:fillRef>
+          <a:effectRef idx="2">
+            <a:schemeClr val="accent1"/>
+          </a:effectRef>
+          <a:fontRef idx="minor">
+            <a:schemeClr val="lt1"/>
+          </a:fontRef>
+        </p:style>
+        <p:txBody>
+          <a:bodyPr rtlCol="0" anchor="ctr"/>
+          <a:lstStyle/>
+          <a:p>
+            <a:pPr algn="ctr"/>
+          </a:p>
+        </p:txBody>
+      </p:sp>
+      <p:sp>
+        <p:nvSpPr>
+          <p:cNvPr id="6" name="Rectangle 5"/>
+          <p:cNvSpPr/>
+          <p:nvPr/>
+        </p:nvSpPr>
+        <p:spPr>
+          <a:xfrm>
+            <a:off x="685800" y="502920"/>
+            <a:ext cx="36576" cy="658368"/>
+          </a:xfrm>
+          <a:prstGeom prst="rect">
+            <a:avLst/>
+          </a:prstGeom>
+          <a:solidFill>
+            <a:srgbClr val="D9C089"/>
+          </a:solidFill>
+          <a:ln>
+            <a:noFill/>
+          </a:ln>
+        </p:spPr>
+        <p:style>
+          <a:lnRef idx="1">
+            <a:schemeClr val="accent1"/>
+          </a:lnRef>
+          <a:fillRef idx="3">
+            <a:schemeClr val="accent1"/>
+          </a:fillRef>
+          <a:effectRef idx="2">
+            <a:schemeClr val="accent1"/>
+          </a:effectRef>
+          <a:fontRef idx="minor">
+            <a:schemeClr val="lt1"/>
+          </a:fontRef>
+        </p:style>
+        <p:txBody>
+          <a:bodyPr rtlCol="0" anchor="ctr"/>
+          <a:lstStyle/>
+          <a:p>
+            <a:pPr algn="ctr"/>
+          </a:p>
+        </p:txBody>
+      </p:sp>
+      <p:sp>
+        <p:nvSpPr>
+          <p:cNvPr id="7" name="TextBox 6"/>
+          <p:cNvSpPr txBox="1"/>
+          <p:nvPr/>
+        </p:nvSpPr>
+        <p:spPr>
+          <a:xfrm>
+            <a:off x="813816" y="502920"/>
+            <a:ext cx="10634472" cy="685800"/>
+          </a:xfrm>
+          <a:prstGeom prst="rect">
+            <a:avLst/>
+          </a:prstGeom>
+          <a:noFill/>
+        </p:spPr>
+        <p:txBody>
+          <a:bodyPr wrap="square">
+            <a:spAutoFit/>
+          </a:bodyPr>
+          <a:lstStyle/>
+          <a:p>
+            <a:pPr algn="l"/>
+            <a:r>
+              <a:rPr sz="2400" b="1" i="0">
+                <a:solidFill>
+                  <a:srgbClr val="1F2C56"/>
+                </a:solidFill>
+                <a:latin typeface="Arial"/>
+              </a:rPr>
+              <a:t>Prinzip dieses Moduls</a:t>
+            </a:r>
+          </a:p>
+        </p:txBody>
+      </p:sp>
+      <p:sp>
+        <p:nvSpPr>
+          <p:cNvPr id="8" name="TextBox 7"/>
+          <p:cNvSpPr txBox="1"/>
+          <p:nvPr/>
+        </p:nvSpPr>
+        <p:spPr>
+          <a:xfrm>
+            <a:off x="685800" y="1417320"/>
+            <a:ext cx="10817352" cy="4892040"/>
+          </a:xfrm>
+          <a:prstGeom prst="rect">
+            <a:avLst/>
+          </a:prstGeom>
+          <a:noFill/>
+        </p:spPr>
+        <p:txBody>
+          <a:bodyPr wrap="square" anchor="ctr">
+            <a:spAutoFit/>
+          </a:bodyPr>
+          <a:lstStyle/>
+          <a:p>
+            <a:pPr marL="177800" indent="-177800">
+              <a:spcBef>
+                <a:spcPts val="600"/>
+              </a:spcBef>
+              <a:spcAft>
+                <a:spcPts val="200"/>
+              </a:spcAft>
+            </a:pPr>
+            <a:r>
+              <a:rPr sz="1200" i="1">
+                <a:solidFill>
+                  <a:srgbClr val="3D5466"/>
+                </a:solidFill>
+                <a:latin typeface="Arial"/>
+              </a:rPr>
+              <a:t>→  Klare Absprachen ersetzen ständige Rückfragen.</a:t>
+            </a:r>
+          </a:p>
+          <a:p>
+            <a:pPr marL="190500" indent="-190500">
+              <a:spcBef>
+                <a:spcPts val="400"/>
+              </a:spcBef>
+              <a:spcAft>
+                <a:spcPts val="200"/>
+              </a:spcAft>
+            </a:pPr>
+            <a:r>
+              <a:rPr sz="1300">
+                <a:solidFill>
+                  <a:srgbClr val="3D5466"/>
+                </a:solidFill>
+                <a:latin typeface="Arial"/>
+              </a:rPr>
+              <a:t>▸  Wer Rollen und Übergaberegeln aktiv vereinbart, verhindert Reibung, bevor sie entsteht.</a:t>
+            </a:r>
+          </a:p>
+        </p:txBody>
+      </p:sp>
+      <p:sp>
+        <p:nvSpPr>
+          <p:cNvPr id="9" name="Rectangle 8"/>
+          <p:cNvSpPr/>
+          <p:nvPr/>
+        </p:nvSpPr>
+        <p:spPr>
+          <a:xfrm>
+            <a:off x="0" y="6510528"/>
+            <a:ext cx="12188952" cy="347472"/>
+          </a:xfrm>
+          <a:prstGeom prst="rect">
+            <a:avLst/>
+          </a:prstGeom>
+          <a:solidFill>
+            <a:srgbClr val="0A1937"/>
+          </a:solidFill>
+          <a:ln>
+            <a:noFill/>
+          </a:ln>
+        </p:spPr>
+        <p:style>
+          <a:lnRef idx="1">
+            <a:schemeClr val="accent1"/>
+          </a:lnRef>
+          <a:fillRef idx="3">
+            <a:schemeClr val="accent1"/>
+          </a:fillRef>
+          <a:effectRef idx="2">
+            <a:schemeClr val="accent1"/>
+          </a:effectRef>
+          <a:fontRef idx="minor">
+            <a:schemeClr val="lt1"/>
+          </a:fontRef>
+        </p:style>
+        <p:txBody>
+          <a:bodyPr rtlCol="0" anchor="ctr"/>
+          <a:lstStyle/>
+          <a:p>
+            <a:pPr algn="ctr"/>
+          </a:p>
+        </p:txBody>
+      </p:sp>
+      <p:sp>
+        <p:nvSpPr>
+          <p:cNvPr id="10" name="TextBox 9"/>
+          <p:cNvSpPr txBox="1"/>
+          <p:nvPr/>
+        </p:nvSpPr>
+        <p:spPr>
+          <a:xfrm>
+            <a:off x="685800" y="6583680"/>
+            <a:ext cx="6490411" cy="256032"/>
+          </a:xfrm>
+          <a:prstGeom prst="rect">
+            <a:avLst/>
+          </a:prstGeom>
+          <a:noFill/>
+        </p:spPr>
+        <p:txBody>
+          <a:bodyPr wrap="none">
+            <a:spAutoFit/>
+          </a:bodyPr>
+          <a:lstStyle/>
+          <a:p>
+            <a:pPr algn="l"/>
+            <a:r>
+              <a:rPr sz="700">
+                <a:solidFill>
+                  <a:srgbClr val="A0B4D2"/>
+                </a:solidFill>
+                <a:latin typeface="Consolas"/>
+              </a:rPr>
+              <a:t>FKB Campus  ·  VA07</a:t>
+            </a:r>
+          </a:p>
+        </p:txBody>
+      </p:sp>
+    </p:spTree>
+  </p:cSld>
+  <p:clrMapOvr>
+    <a:masterClrMapping/>
+  </p:clrMapOvr>
+</p:sld>
+</file>
+
+<file path=ppt/slides/slide16.xml><?xml version="1.0" encoding="utf-8"?>
+<p:sld xmlns:a="http://schemas.openxmlformats.org/drawingml/2006/main" xmlns:p="http://schemas.openxmlformats.org/presentationml/2006/main" xmlns:r="http://schemas.openxmlformats.org/officeDocument/2006/relationships">
+  <p:cSld>
+    <p:spTree>
+      <p:nvGrpSpPr>
+        <p:cNvPr id="1" name=""/>
+        <p:cNvGrpSpPr/>
+        <p:nvPr/>
+      </p:nvGrpSpPr>
+      <p:grpSpPr/>
+      <p:sp>
+        <p:nvSpPr>
+          <p:cNvPr id="2" name="Rectangle 1"/>
+          <p:cNvSpPr/>
+          <p:nvPr/>
+        </p:nvSpPr>
+        <p:spPr>
+          <a:xfrm>
+            <a:off x="0" y="0"/>
+            <a:ext cx="12188952" cy="6858000"/>
+          </a:xfrm>
+          <a:prstGeom prst="rect">
+            <a:avLst/>
+          </a:prstGeom>
+          <a:solidFill>
+            <a:srgbClr val="EDEDF3"/>
+          </a:solidFill>
+          <a:ln>
+            <a:noFill/>
+          </a:ln>
+        </p:spPr>
+        <p:style>
+          <a:lnRef idx="1">
+            <a:schemeClr val="accent1"/>
+          </a:lnRef>
+          <a:fillRef idx="3">
+            <a:schemeClr val="accent1"/>
+          </a:fillRef>
+          <a:effectRef idx="2">
+            <a:schemeClr val="accent1"/>
+          </a:effectRef>
+          <a:fontRef idx="minor">
+            <a:schemeClr val="lt1"/>
+          </a:fontRef>
+        </p:style>
+        <p:txBody>
+          <a:bodyPr rtlCol="0" anchor="ctr"/>
+          <a:lstStyle/>
+          <a:p>
+            <a:pPr algn="ctr"/>
+          </a:p>
+        </p:txBody>
+      </p:sp>
+      <p:sp>
+        <p:nvSpPr>
+          <p:cNvPr id="3" name="Rectangle 2"/>
+          <p:cNvSpPr/>
+          <p:nvPr/>
+        </p:nvSpPr>
+        <p:spPr>
+          <a:xfrm>
+            <a:off x="0" y="0"/>
+            <a:ext cx="12188952" cy="50292"/>
+          </a:xfrm>
+          <a:prstGeom prst="rect">
+            <a:avLst/>
+          </a:prstGeom>
+          <a:solidFill>
+            <a:srgbClr val="1F2C56"/>
+          </a:solidFill>
+          <a:ln>
+            <a:noFill/>
+          </a:ln>
+        </p:spPr>
+        <p:style>
+          <a:lnRef idx="1">
+            <a:schemeClr val="accent1"/>
+          </a:lnRef>
+          <a:fillRef idx="3">
+            <a:schemeClr val="accent1"/>
+          </a:fillRef>
+          <a:effectRef idx="2">
+            <a:schemeClr val="accent1"/>
+          </a:effectRef>
+          <a:fontRef idx="minor">
+            <a:schemeClr val="lt1"/>
+          </a:fontRef>
+        </p:style>
+        <p:txBody>
+          <a:bodyPr rtlCol="0" anchor="ctr"/>
+          <a:lstStyle/>
+          <a:p>
+            <a:pPr algn="ctr"/>
+          </a:p>
+        </p:txBody>
+      </p:sp>
+      <p:sp>
+        <p:nvSpPr>
+          <p:cNvPr id="4" name="TextBox 3"/>
+          <p:cNvSpPr txBox="1"/>
+          <p:nvPr/>
+        </p:nvSpPr>
+        <p:spPr>
+          <a:xfrm>
+            <a:off x="685800" y="109728"/>
+            <a:ext cx="10817352" cy="228600"/>
+          </a:xfrm>
+          <a:prstGeom prst="rect">
+            <a:avLst/>
+          </a:prstGeom>
+          <a:noFill/>
+        </p:spPr>
+        <p:txBody>
+          <a:bodyPr wrap="none">
+            <a:spAutoFit/>
+          </a:bodyPr>
+          <a:lstStyle/>
+          <a:p>
+            <a:pPr algn="l"/>
+            <a:r>
+              <a:rPr sz="750">
+                <a:solidFill>
+                  <a:srgbClr val="78808C"/>
+                </a:solidFill>
+                <a:latin typeface="Consolas"/>
+              </a:rPr>
+              <a:t>VA07  ·  INHALT</a:t>
+            </a:r>
+          </a:p>
+        </p:txBody>
+      </p:sp>
+      <p:sp>
+        <p:nvSpPr>
+          <p:cNvPr id="5" name="Rectangle 4"/>
+          <p:cNvSpPr/>
+          <p:nvPr/>
+        </p:nvSpPr>
+        <p:spPr>
+          <a:xfrm>
+            <a:off x="0" y="1234440"/>
+            <a:ext cx="12188952" cy="12700"/>
+          </a:xfrm>
+          <a:prstGeom prst="rect">
+            <a:avLst/>
+          </a:prstGeom>
+          <a:solidFill>
+            <a:srgbClr val="D8DFE4"/>
+          </a:solidFill>
+          <a:ln>
+            <a:noFill/>
+          </a:ln>
+        </p:spPr>
+        <p:style>
+          <a:lnRef idx="1">
+            <a:schemeClr val="accent1"/>
+          </a:lnRef>
+          <a:fillRef idx="3">
+            <a:schemeClr val="accent1"/>
+          </a:fillRef>
+          <a:effectRef idx="2">
+            <a:schemeClr val="accent1"/>
+          </a:effectRef>
+          <a:fontRef idx="minor">
+            <a:schemeClr val="lt1"/>
+          </a:fontRef>
+        </p:style>
+        <p:txBody>
+          <a:bodyPr rtlCol="0" anchor="ctr"/>
+          <a:lstStyle/>
+          <a:p>
+            <a:pPr algn="ctr"/>
+          </a:p>
+        </p:txBody>
+      </p:sp>
+      <p:sp>
+        <p:nvSpPr>
+          <p:cNvPr id="6" name="Rectangle 5"/>
+          <p:cNvSpPr/>
+          <p:nvPr/>
+        </p:nvSpPr>
+        <p:spPr>
+          <a:xfrm>
+            <a:off x="685800" y="502920"/>
+            <a:ext cx="36576" cy="658368"/>
+          </a:xfrm>
+          <a:prstGeom prst="rect">
+            <a:avLst/>
+          </a:prstGeom>
+          <a:solidFill>
+            <a:srgbClr val="D9C089"/>
+          </a:solidFill>
+          <a:ln>
+            <a:noFill/>
+          </a:ln>
+        </p:spPr>
+        <p:style>
+          <a:lnRef idx="1">
+            <a:schemeClr val="accent1"/>
+          </a:lnRef>
+          <a:fillRef idx="3">
+            <a:schemeClr val="accent1"/>
+          </a:fillRef>
+          <a:effectRef idx="2">
+            <a:schemeClr val="accent1"/>
+          </a:effectRef>
+          <a:fontRef idx="minor">
+            <a:schemeClr val="lt1"/>
+          </a:fontRef>
+        </p:style>
+        <p:txBody>
+          <a:bodyPr rtlCol="0" anchor="ctr"/>
+          <a:lstStyle/>
+          <a:p>
+            <a:pPr algn="ctr"/>
+          </a:p>
+        </p:txBody>
+      </p:sp>
+      <p:sp>
+        <p:nvSpPr>
+          <p:cNvPr id="7" name="TextBox 6"/>
+          <p:cNvSpPr txBox="1"/>
+          <p:nvPr/>
+        </p:nvSpPr>
+        <p:spPr>
+          <a:xfrm>
+            <a:off x="813816" y="502920"/>
+            <a:ext cx="10634472" cy="685800"/>
+          </a:xfrm>
+          <a:prstGeom prst="rect">
+            <a:avLst/>
+          </a:prstGeom>
+          <a:noFill/>
+        </p:spPr>
+        <p:txBody>
+          <a:bodyPr wrap="square">
+            <a:spAutoFit/>
+          </a:bodyPr>
+          <a:lstStyle/>
+          <a:p>
+            <a:pPr algn="l"/>
+            <a:r>
+              <a:rPr sz="2400" b="1" i="0">
+                <a:solidFill>
+                  <a:srgbClr val="1F2C56"/>
+                </a:solidFill>
+                <a:latin typeface="Arial"/>
+              </a:rPr>
+              <a:t>Reflexionsfragen</a:t>
+            </a:r>
+          </a:p>
+        </p:txBody>
+      </p:sp>
+      <p:sp>
+        <p:nvSpPr>
+          <p:cNvPr id="8" name="TextBox 7"/>
+          <p:cNvSpPr txBox="1"/>
+          <p:nvPr/>
+        </p:nvSpPr>
+        <p:spPr>
+          <a:xfrm>
+            <a:off x="685800" y="1417320"/>
+            <a:ext cx="10817352" cy="4892040"/>
+          </a:xfrm>
+          <a:prstGeom prst="rect">
+            <a:avLst/>
+          </a:prstGeom>
+          <a:noFill/>
+        </p:spPr>
+        <p:txBody>
+          <a:bodyPr wrap="square" anchor="ctr">
+            <a:spAutoFit/>
+          </a:bodyPr>
+          <a:lstStyle/>
+          <a:p>
+            <a:pPr marL="190500" indent="-190500">
+              <a:spcBef>
+                <a:spcPts val="400"/>
+              </a:spcBef>
+              <a:spcAft>
+                <a:spcPts val="200"/>
+              </a:spcAft>
+            </a:pPr>
+            <a:r>
+              <a:rPr sz="1300">
+                <a:solidFill>
+                  <a:srgbClr val="3D5466"/>
+                </a:solidFill>
+                <a:latin typeface="Arial"/>
+              </a:rPr>
+              <a:t>▸  An welcher Schnittstelle entsteht bei Ihnen die meiste Reibung – und ist es Zuständigkeit, Information oder Priorität?</a:t>
+            </a:r>
+          </a:p>
+          <a:p>
+            <a:pPr marL="190500" indent="-190500">
+              <a:spcBef>
+                <a:spcPts val="400"/>
+              </a:spcBef>
+              <a:spcAft>
+                <a:spcPts val="200"/>
+              </a:spcAft>
+            </a:pPr>
+            <a:r>
+              <a:rPr sz="1300">
+                <a:solidFill>
+                  <a:srgbClr val="3D5466"/>
+                </a:solidFill>
+                <a:latin typeface="Arial"/>
+              </a:rPr>
+              <a:t>▸  Welche Übergaberegel würden Sie mit Ihren Beratern gern vereinbaren?</a:t>
+            </a:r>
+          </a:p>
+          <a:p>
+            <a:pPr marL="190500" indent="-190500">
+              <a:spcBef>
+                <a:spcPts val="400"/>
+              </a:spcBef>
+              <a:spcAft>
+                <a:spcPts val="200"/>
+              </a:spcAft>
+            </a:pPr>
+            <a:r>
+              <a:rPr sz="1300">
+                <a:solidFill>
+                  <a:srgbClr val="3D5466"/>
+                </a:solidFill>
+                <a:latin typeface="Arial"/>
+              </a:rPr>
+              <a:t>▸  Wann haben Sie zuletzt eine Zusage nicht gehalten – und wie hätten Sie es früher zurückmelden können?</a:t>
+            </a:r>
+          </a:p>
+        </p:txBody>
+      </p:sp>
+      <p:sp>
+        <p:nvSpPr>
+          <p:cNvPr id="9" name="Rectangle 8"/>
+          <p:cNvSpPr/>
+          <p:nvPr/>
+        </p:nvSpPr>
+        <p:spPr>
+          <a:xfrm>
+            <a:off x="0" y="6510528"/>
+            <a:ext cx="12188952" cy="347472"/>
+          </a:xfrm>
+          <a:prstGeom prst="rect">
+            <a:avLst/>
+          </a:prstGeom>
+          <a:solidFill>
+            <a:srgbClr val="0A1937"/>
+          </a:solidFill>
+          <a:ln>
+            <a:noFill/>
+          </a:ln>
+        </p:spPr>
+        <p:style>
+          <a:lnRef idx="1">
+            <a:schemeClr val="accent1"/>
+          </a:lnRef>
+          <a:fillRef idx="3">
+            <a:schemeClr val="accent1"/>
+          </a:fillRef>
+          <a:effectRef idx="2">
+            <a:schemeClr val="accent1"/>
+          </a:effectRef>
+          <a:fontRef idx="minor">
+            <a:schemeClr val="lt1"/>
+          </a:fontRef>
+        </p:style>
+        <p:txBody>
+          <a:bodyPr rtlCol="0" anchor="ctr"/>
+          <a:lstStyle/>
+          <a:p>
+            <a:pPr algn="ctr"/>
+          </a:p>
+        </p:txBody>
+      </p:sp>
+      <p:sp>
+        <p:nvSpPr>
+          <p:cNvPr id="10" name="TextBox 9"/>
+          <p:cNvSpPr txBox="1"/>
+          <p:nvPr/>
+        </p:nvSpPr>
+        <p:spPr>
+          <a:xfrm>
+            <a:off x="685800" y="6583680"/>
+            <a:ext cx="6490411" cy="256032"/>
+          </a:xfrm>
+          <a:prstGeom prst="rect">
+            <a:avLst/>
+          </a:prstGeom>
+          <a:noFill/>
+        </p:spPr>
+        <p:txBody>
+          <a:bodyPr wrap="none">
+            <a:spAutoFit/>
+          </a:bodyPr>
+          <a:lstStyle/>
+          <a:p>
+            <a:pPr algn="l"/>
+            <a:r>
+              <a:rPr sz="700">
+                <a:solidFill>
+                  <a:srgbClr val="A0B4D2"/>
+                </a:solidFill>
+                <a:latin typeface="Consolas"/>
+              </a:rPr>
+              <a:t>FKB Campus  ·  VA07</a:t>
+            </a:r>
+          </a:p>
+        </p:txBody>
+      </p:sp>
+    </p:spTree>
+  </p:cSld>
+  <p:clrMapOvr>
+    <a:masterClrMapping/>
+  </p:clrMapOvr>
+</p:sld>
+</file>
+
 <file path=ppt/slides/slide2.xml><?xml version="1.0" encoding="utf-8"?>
 <p:sld xmlns:a="http://schemas.openxmlformats.org/drawingml/2006/main" xmlns:p="http://schemas.openxmlformats.org/presentationml/2006/main" xmlns:r="http://schemas.openxmlformats.org/officeDocument/2006/relationships">
   <p:cSld>
@@ -5798,7 +8899,7 @@
             <a:avLst/>
           </a:prstGeom>
           <a:solidFill>
-            <a:srgbClr val="EDEDF3"/>
+            <a:srgbClr val="1F2C56"/>
           </a:solidFill>
           <a:ln>
             <a:noFill/>
@@ -5828,57 +8929,14 @@
       </p:sp>
       <p:sp>
         <p:nvSpPr>
-          <p:cNvPr id="3" name="Rectangle 2"/>
-          <p:cNvSpPr/>
-          <p:nvPr/>
-        </p:nvSpPr>
-        <p:spPr>
-          <a:xfrm>
-            <a:off x="0" y="0"/>
-            <a:ext cx="12188952" cy="50292"/>
-          </a:xfrm>
-          <a:prstGeom prst="rect">
-            <a:avLst/>
-          </a:prstGeom>
-          <a:solidFill>
-            <a:srgbClr val="1F2C56"/>
-          </a:solidFill>
-          <a:ln>
-            <a:noFill/>
-          </a:ln>
-        </p:spPr>
-        <p:style>
-          <a:lnRef idx="1">
-            <a:schemeClr val="accent1"/>
-          </a:lnRef>
-          <a:fillRef idx="3">
-            <a:schemeClr val="accent1"/>
-          </a:fillRef>
-          <a:effectRef idx="2">
-            <a:schemeClr val="accent1"/>
-          </a:effectRef>
-          <a:fontRef idx="minor">
-            <a:schemeClr val="lt1"/>
-          </a:fontRef>
-        </p:style>
-        <p:txBody>
-          <a:bodyPr rtlCol="0" anchor="ctr"/>
-          <a:lstStyle/>
-          <a:p>
-            <a:pPr algn="ctr"/>
-          </a:p>
-        </p:txBody>
-      </p:sp>
-      <p:sp>
-        <p:nvSpPr>
-          <p:cNvPr id="4" name="TextBox 3"/>
+          <p:cNvPr id="3" name="TextBox 2"/>
           <p:cNvSpPr txBox="1"/>
           <p:nvPr/>
         </p:nvSpPr>
         <p:spPr>
           <a:xfrm>
-            <a:off x="685800" y="109728"/>
-            <a:ext cx="10817352" cy="228600"/>
+            <a:off x="685800" y="2377440"/>
+            <a:ext cx="10817352" cy="365760"/>
           </a:xfrm>
           <a:prstGeom prst="rect">
             <a:avLst/>
@@ -5893,70 +8951,27 @@
           <a:p>
             <a:pPr algn="l"/>
             <a:r>
-              <a:rPr sz="750">
-                <a:solidFill>
-                  <a:srgbClr val="78808C"/>
+              <a:rPr sz="1200">
+                <a:solidFill>
+                  <a:srgbClr val="D9C089"/>
                 </a:solidFill>
                 <a:latin typeface="Consolas"/>
               </a:rPr>
-              <a:t>VA07  ·  INHALT</a:t>
-            </a:r>
-          </a:p>
-        </p:txBody>
-      </p:sp>
-      <p:sp>
-        <p:nvSpPr>
-          <p:cNvPr id="5" name="Rectangle 4"/>
+              <a:t>00:05–00:20</a:t>
+            </a:r>
+          </a:p>
+        </p:txBody>
+      </p:sp>
+      <p:sp>
+        <p:nvSpPr>
+          <p:cNvPr id="4" name="Rectangle 3"/>
           <p:cNvSpPr/>
           <p:nvPr/>
         </p:nvSpPr>
         <p:spPr>
           <a:xfrm>
-            <a:off x="0" y="1234440"/>
-            <a:ext cx="12188952" cy="12700"/>
-          </a:xfrm>
-          <a:prstGeom prst="rect">
-            <a:avLst/>
-          </a:prstGeom>
-          <a:solidFill>
-            <a:srgbClr val="D8DFE4"/>
-          </a:solidFill>
-          <a:ln>
-            <a:noFill/>
-          </a:ln>
-        </p:spPr>
-        <p:style>
-          <a:lnRef idx="1">
-            <a:schemeClr val="accent1"/>
-          </a:lnRef>
-          <a:fillRef idx="3">
-            <a:schemeClr val="accent1"/>
-          </a:fillRef>
-          <a:effectRef idx="2">
-            <a:schemeClr val="accent1"/>
-          </a:effectRef>
-          <a:fontRef idx="minor">
-            <a:schemeClr val="lt1"/>
-          </a:fontRef>
-        </p:style>
-        <p:txBody>
-          <a:bodyPr rtlCol="0" anchor="ctr"/>
-          <a:lstStyle/>
-          <a:p>
-            <a:pPr algn="ctr"/>
-          </a:p>
-        </p:txBody>
-      </p:sp>
-      <p:sp>
-        <p:nvSpPr>
-          <p:cNvPr id="6" name="Rectangle 5"/>
-          <p:cNvSpPr/>
-          <p:nvPr/>
-        </p:nvSpPr>
-        <p:spPr>
-          <a:xfrm>
-            <a:off x="685800" y="502920"/>
-            <a:ext cx="36576" cy="658368"/>
+            <a:off x="685800" y="2788920"/>
+            <a:ext cx="548640" cy="38100"/>
           </a:xfrm>
           <a:prstGeom prst="rect">
             <a:avLst/>
@@ -5992,14 +9007,14 @@
       </p:sp>
       <p:sp>
         <p:nvSpPr>
-          <p:cNvPr id="7" name="TextBox 6"/>
+          <p:cNvPr id="5" name="TextBox 4"/>
           <p:cNvSpPr txBox="1"/>
           <p:nvPr/>
         </p:nvSpPr>
         <p:spPr>
           <a:xfrm>
-            <a:off x="813816" y="502920"/>
-            <a:ext cx="10634472" cy="685800"/>
+            <a:off x="685800" y="3017520"/>
+            <a:ext cx="10817352" cy="1463040"/>
           </a:xfrm>
           <a:prstGeom prst="rect">
             <a:avLst/>
@@ -6014,27 +9029,27 @@
           <a:p>
             <a:pPr algn="l"/>
             <a:r>
-              <a:rPr sz="2400" b="1" i="0">
-                <a:solidFill>
-                  <a:srgbClr val="1F2C56"/>
+              <a:rPr sz="4000" b="1" i="0">
+                <a:solidFill>
+                  <a:srgbClr val="FFFFFF"/>
                 </a:solidFill>
                 <a:latin typeface="Arial"/>
               </a:rPr>
-              <a:t>Theorie-Input: Die Schnittstelle ist eine Rollenbeziehung</a:t>
-            </a:r>
-          </a:p>
-        </p:txBody>
-      </p:sp>
-      <p:sp>
-        <p:nvSpPr>
-          <p:cNvPr id="8" name="TextBox 7"/>
+              <a:t>Theorie-Input 1</a:t>
+            </a:r>
+          </a:p>
+        </p:txBody>
+      </p:sp>
+      <p:sp>
+        <p:nvSpPr>
+          <p:cNvPr id="6" name="TextBox 5"/>
           <p:cNvSpPr txBox="1"/>
           <p:nvPr/>
         </p:nvSpPr>
         <p:spPr>
           <a:xfrm>
-            <a:off x="685800" y="1417320"/>
-            <a:ext cx="10817352" cy="4892040"/>
+            <a:off x="685800" y="4480560"/>
+            <a:ext cx="8653881" cy="1280160"/>
           </a:xfrm>
           <a:prstGeom prst="rect">
             <a:avLst/>
@@ -6042,141 +9057,34 @@
           <a:noFill/>
         </p:spPr>
         <p:txBody>
-          <a:bodyPr wrap="square" anchor="ctr">
+          <a:bodyPr wrap="square">
             <a:spAutoFit/>
           </a:bodyPr>
           <a:lstStyle/>
           <a:p>
-            <a:pPr marL="190500" indent="-190500">
-              <a:spcBef>
-                <a:spcPts val="400"/>
-              </a:spcBef>
-              <a:spcAft>
-                <a:spcPts val="200"/>
-              </a:spcAft>
-            </a:pPr>
-            <a:r>
-              <a:rPr sz="1300">
-                <a:solidFill>
-                  <a:srgbClr val="3D5466"/>
+            <a:pPr algn="l"/>
+            <a:r>
+              <a:rPr sz="1600" b="0" i="0">
+                <a:solidFill>
+                  <a:srgbClr val="C8D2E6"/>
                 </a:solidFill>
                 <a:latin typeface="Arial"/>
               </a:rPr>
-              <a:t>▸  Rollenklarheit: Ist klar, wer was übernimmt? (senkt Reibung)</a:t>
-            </a:r>
-          </a:p>
-          <a:p>
-            <a:pPr marL="190500" indent="-190500">
-              <a:spcBef>
-                <a:spcPts val="400"/>
-              </a:spcBef>
-              <a:spcAft>
-                <a:spcPts val="200"/>
-              </a:spcAft>
-            </a:pPr>
-            <a:r>
-              <a:rPr sz="1300">
-                <a:solidFill>
-                  <a:srgbClr val="3D5466"/>
-                </a:solidFill>
-                <a:latin typeface="Arial"/>
-              </a:rPr>
-              <a:t>▸  Rollenkonflikt: Widersprüchliche Anforderungen (z. B. zwei Berater wollen „sofort").</a:t>
-            </a:r>
-          </a:p>
-          <a:p>
-            <a:pPr marL="190500" indent="-190500">
-              <a:spcBef>
-                <a:spcPts val="400"/>
-              </a:spcBef>
-              <a:spcAft>
-                <a:spcPts val="200"/>
-              </a:spcAft>
-            </a:pPr>
-            <a:r>
-              <a:rPr sz="1300">
-                <a:solidFill>
-                  <a:srgbClr val="3D5466"/>
-                </a:solidFill>
-                <a:latin typeface="Arial"/>
-              </a:rPr>
-              <a:t>▸  Rollenaushandlung: Erwartungen werden aktiv besprochen, nicht vermutet.</a:t>
-            </a:r>
-          </a:p>
-          <a:p>
-            <a:pPr marL="190500" indent="-190500">
-              <a:spcBef>
-                <a:spcPts val="400"/>
-              </a:spcBef>
-              <a:spcAft>
-                <a:spcPts val="200"/>
-              </a:spcAft>
-            </a:pPr>
-            <a:r>
-              <a:rPr sz="1300">
-                <a:solidFill>
-                  <a:srgbClr val="3D5466"/>
-                </a:solidFill>
-                <a:latin typeface="Arial"/>
-              </a:rPr>
-              <a:t>▸  Gute Zusammenarbeit entsteht nicht von selbst, sondern wird ausgehandelt und eingeübt – sie ist Teil einer gemeinsamen Praxis (Wenger, 1998 ).</a:t>
-            </a:r>
-          </a:p>
-        </p:txBody>
-      </p:sp>
-      <p:sp>
-        <p:nvSpPr>
-          <p:cNvPr id="9" name="Rectangle 8"/>
-          <p:cNvSpPr/>
-          <p:nvPr/>
-        </p:nvSpPr>
-        <p:spPr>
-          <a:xfrm>
-            <a:off x="0" y="6510528"/>
-            <a:ext cx="12188952" cy="347472"/>
-          </a:xfrm>
-          <a:prstGeom prst="rect">
-            <a:avLst/>
-          </a:prstGeom>
-          <a:solidFill>
-            <a:srgbClr val="0A1937"/>
-          </a:solidFill>
-          <a:ln>
-            <a:noFill/>
-          </a:ln>
-        </p:spPr>
-        <p:style>
-          <a:lnRef idx="1">
-            <a:schemeClr val="accent1"/>
-          </a:lnRef>
-          <a:fillRef idx="3">
-            <a:schemeClr val="accent1"/>
-          </a:fillRef>
-          <a:effectRef idx="2">
-            <a:schemeClr val="accent1"/>
-          </a:effectRef>
-          <a:fontRef idx="minor">
-            <a:schemeClr val="lt1"/>
-          </a:fontRef>
-        </p:style>
-        <p:txBody>
-          <a:bodyPr rtlCol="0" anchor="ctr"/>
-          <a:lstStyle/>
-          <a:p>
-            <a:pPr algn="ctr"/>
-          </a:p>
-        </p:txBody>
-      </p:sp>
-      <p:sp>
-        <p:nvSpPr>
-          <p:cNvPr id="10" name="TextBox 9"/>
+              <a:t>Die eigene Rolle im Erwartungsgeflecht verstehen (role set).</a:t>
+            </a:r>
+          </a:p>
+        </p:txBody>
+      </p:sp>
+      <p:sp>
+        <p:nvSpPr>
+          <p:cNvPr id="7" name="TextBox 6"/>
           <p:cNvSpPr txBox="1"/>
           <p:nvPr/>
         </p:nvSpPr>
         <p:spPr>
           <a:xfrm>
-            <a:off x="685800" y="6583680"/>
-            <a:ext cx="6490411" cy="256032"/>
+            <a:off x="685800" y="6355080"/>
+            <a:ext cx="10817352" cy="274320"/>
           </a:xfrm>
           <a:prstGeom prst="rect">
             <a:avLst/>
@@ -6193,7 +9101,7 @@
             <a:r>
               <a:rPr sz="700">
                 <a:solidFill>
-                  <a:srgbClr val="A0B4D2"/>
+                  <a:srgbClr val="8CA0C3"/>
                 </a:solidFill>
                 <a:latin typeface="Consolas"/>
               </a:rPr>
@@ -6457,7 +9365,7 @@
                 </a:solidFill>
                 <a:latin typeface="Arial"/>
               </a:rPr>
-              <a:t>Theorie-Input: Von Reibung zu Regeln</a:t>
+              <a:t>Die Assistenz im Rollengeflecht</a:t>
             </a:r>
           </a:p>
         </p:txBody>
@@ -6483,6 +9391,25 @@
             <a:spAutoFit/>
           </a:bodyPr>
           <a:lstStyle/>
+          <a:p>
+            <a:pPr marL="177800" indent="-177800">
+              <a:spcBef>
+                <a:spcPts val="600"/>
+              </a:spcBef>
+              <a:spcAft>
+                <a:spcPts val="200"/>
+              </a:spcAft>
+            </a:pPr>
+            <a:r>
+              <a:rPr sz="1200" i="1">
+                <a:solidFill>
+                  <a:srgbClr val="3D5466"/>
+                </a:solidFill>
+                <a:latin typeface="Arial"/>
+              </a:rPr>
+              <a:t>→  Jede Position steht im Zentrum von Erwartungen verschiedener Beteiligter – dem role set (Katz &amp; Kahn, 1978). Die Assistenz erlebt das täglich.</a:t>
+            </a:r>
+          </a:p>
           <a:p>
             <a:pPr marL="190500" indent="-190500">
               <a:spcBef>
@@ -6499,7 +9426,7 @@
                 </a:solidFill>
                 <a:latin typeface="Arial"/>
               </a:rPr>
-              <a:t>▸  Übergaberegeln: Was wird wie und wann übergeben? (z. B. Auftrag immer im System, nicht per Zuruf)</a:t>
+              <a:t>▸  Rollenklarheit: Ist klar, wer was übernimmt? Das senkt Reibung.</a:t>
             </a:r>
           </a:p>
           <a:p>
@@ -6518,7 +9445,7 @@
                 </a:solidFill>
                 <a:latin typeface="Arial"/>
               </a:rPr>
-              <a:t>▸  Erreichbarkeit/Reaktionszeiten: Wann erwartet wer was?</a:t>
+              <a:t>▸  Rollenkonflikt: widersprüchliche Anforderungen – z. B. zwei Berater wollen gleichzeitig „sofort".</a:t>
             </a:r>
           </a:p>
           <a:p>
@@ -6537,26 +9464,7 @@
                 </a:solidFill>
                 <a:latin typeface="Arial"/>
               </a:rPr>
-              <a:t>▸  Priorisierungsregel: Wie wird entschieden, wenn alles „dringend" ist?</a:t>
-            </a:r>
-          </a:p>
-          <a:p>
-            <a:pPr marL="190500" indent="-190500">
-              <a:spcBef>
-                <a:spcPts val="400"/>
-              </a:spcBef>
-              <a:spcAft>
-                <a:spcPts val="200"/>
-              </a:spcAft>
-            </a:pPr>
-            <a:r>
-              <a:rPr sz="1300">
-                <a:solidFill>
-                  <a:srgbClr val="3D5466"/>
-                </a:solidFill>
-                <a:latin typeface="Arial"/>
-              </a:rPr>
-              <a:t>▸  Solche Regeln einmal gemeinsam festzulegen, spart dauerhaft Diskussionen.</a:t>
+              <a:t>▸  Rollenaushandlung: Erwartungen werden aktiv besprochen, nicht vermutet – das ist der eigentliche Hebel.</a:t>
             </a:r>
           </a:p>
         </p:txBody>
@@ -6672,7 +9580,7 @@
             <a:avLst/>
           </a:prstGeom>
           <a:solidFill>
-            <a:srgbClr val="EDEDF3"/>
+            <a:srgbClr val="FFFFFF"/>
           </a:solidFill>
           <a:ln>
             <a:noFill/>
@@ -6773,51 +9681,43 @@
                 </a:solidFill>
                 <a:latin typeface="Consolas"/>
               </a:rPr>
-              <a:t>VA07  ·  ARBEITSBLATT</a:t>
-            </a:r>
-          </a:p>
-        </p:txBody>
-      </p:sp>
-      <p:sp>
-        <p:nvSpPr>
-          <p:cNvPr id="5" name="Rectangle 4"/>
-          <p:cNvSpPr/>
-          <p:nvPr/>
-        </p:nvSpPr>
-        <p:spPr>
-          <a:xfrm>
-            <a:off x="0" y="1234440"/>
-            <a:ext cx="12188952" cy="12700"/>
-          </a:xfrm>
-          <a:prstGeom prst="rect">
-            <a:avLst/>
-          </a:prstGeom>
-          <a:solidFill>
-            <a:srgbClr val="D8DFE4"/>
-          </a:solidFill>
-          <a:ln>
-            <a:noFill/>
-          </a:ln>
-        </p:spPr>
-        <p:style>
-          <a:lnRef idx="1">
-            <a:schemeClr val="accent1"/>
-          </a:lnRef>
-          <a:fillRef idx="3">
-            <a:schemeClr val="accent1"/>
-          </a:fillRef>
-          <a:effectRef idx="2">
-            <a:schemeClr val="accent1"/>
-          </a:effectRef>
-          <a:fontRef idx="minor">
-            <a:schemeClr val="lt1"/>
-          </a:fontRef>
-        </p:style>
-        <p:txBody>
-          <a:bodyPr rtlCol="0" anchor="ctr"/>
-          <a:lstStyle/>
-          <a:p>
-            <a:pPr algn="ctr"/>
+              <a:t>VA07  ·  SCHAUBILD</a:t>
+            </a:r>
+          </a:p>
+        </p:txBody>
+      </p:sp>
+      <p:sp>
+        <p:nvSpPr>
+          <p:cNvPr id="5" name="TextBox 4"/>
+          <p:cNvSpPr txBox="1"/>
+          <p:nvPr/>
+        </p:nvSpPr>
+        <p:spPr>
+          <a:xfrm>
+            <a:off x="685800" y="502920"/>
+            <a:ext cx="10817352" cy="594360"/>
+          </a:xfrm>
+          <a:prstGeom prst="rect">
+            <a:avLst/>
+          </a:prstGeom>
+          <a:noFill/>
+        </p:spPr>
+        <p:txBody>
+          <a:bodyPr wrap="square">
+            <a:spAutoFit/>
+          </a:bodyPr>
+          <a:lstStyle/>
+          <a:p>
+            <a:pPr algn="l"/>
+            <a:r>
+              <a:rPr sz="2000" b="1" i="0">
+                <a:solidFill>
+                  <a:srgbClr val="1F2C56"/>
+                </a:solidFill>
+                <a:latin typeface="Arial"/>
+              </a:rPr>
+              <a:t>Die Assistenz im Rollengeflecht (role set)</a:t>
+            </a:r>
           </a:p>
         </p:txBody>
       </p:sp>
@@ -6829,8 +9729,8 @@
         </p:nvSpPr>
         <p:spPr>
           <a:xfrm>
-            <a:off x="685800" y="502920"/>
-            <a:ext cx="36576" cy="658368"/>
+            <a:off x="685800" y="1143000"/>
+            <a:ext cx="10817352" cy="25400"/>
           </a:xfrm>
           <a:prstGeom prst="rect">
             <a:avLst/>
@@ -6864,240 +9764,33 @@
           </a:p>
         </p:txBody>
       </p:sp>
-      <p:sp>
-        <p:nvSpPr>
-          <p:cNvPr id="7" name="TextBox 6"/>
-          <p:cNvSpPr txBox="1"/>
-          <p:nvPr/>
-        </p:nvSpPr>
-        <p:spPr>
-          <a:xfrm>
-            <a:off x="813816" y="502920"/>
-            <a:ext cx="10634472" cy="685800"/>
-          </a:xfrm>
-          <a:prstGeom prst="rect">
-            <a:avLst/>
-          </a:prstGeom>
-          <a:noFill/>
-        </p:spPr>
-        <p:txBody>
-          <a:bodyPr wrap="square">
-            <a:spAutoFit/>
-          </a:bodyPr>
-          <a:lstStyle/>
-          <a:p>
-            <a:pPr algn="l"/>
-            <a:r>
-              <a:rPr sz="2400" b="1" i="0">
-                <a:solidFill>
-                  <a:srgbClr val="1F2C56"/>
-                </a:solidFill>
-                <a:latin typeface="Arial"/>
-              </a:rPr>
-              <a:t>Praxisfall: Drei Berater, ein Vormittag</a:t>
-            </a:r>
-          </a:p>
-        </p:txBody>
-      </p:sp>
-      <p:sp>
-        <p:nvSpPr>
-          <p:cNvPr id="8" name="TextBox 7"/>
-          <p:cNvSpPr txBox="1"/>
-          <p:nvPr/>
-        </p:nvSpPr>
-        <p:spPr>
-          <a:xfrm>
-            <a:off x="685800" y="1554480"/>
-            <a:ext cx="10817352" cy="3840480"/>
-          </a:xfrm>
-          <a:prstGeom prst="rect">
-            <a:avLst/>
-          </a:prstGeom>
-          <a:noFill/>
-        </p:spPr>
-        <p:txBody>
-          <a:bodyPr wrap="square">
-            <a:spAutoFit/>
-          </a:bodyPr>
-          <a:lstStyle/>
-          <a:p>
-            <a:pPr marL="190500" indent="-190500">
-              <a:spcBef>
-                <a:spcPts val="400"/>
-              </a:spcBef>
-              <a:spcAft>
-                <a:spcPts val="200"/>
-              </a:spcAft>
-            </a:pPr>
-            <a:r>
-              <a:rPr sz="1400">
-                <a:solidFill>
-                  <a:srgbClr val="3D5466"/>
-                </a:solidFill>
-                <a:latin typeface="Arial"/>
-              </a:rPr>
-              <a:t>▸  Ausgangslage (anonymisiert)</a:t>
-            </a:r>
-          </a:p>
-          <a:p>
-            <a:pPr marL="190500" indent="-190500">
-              <a:spcBef>
-                <a:spcPts val="400"/>
-              </a:spcBef>
-              <a:spcAft>
-                <a:spcPts val="200"/>
-              </a:spcAft>
-            </a:pPr>
-            <a:r>
-              <a:rPr sz="1400">
-                <a:solidFill>
-                  <a:srgbClr val="3D5466"/>
-                </a:solidFill>
-                <a:latin typeface="Arial"/>
-              </a:rPr>
-              <a:t>▸  Sie unterstützen im Innendienst drei Berater (VR-Bank Musterregion eG). An einem Vormittag:</a:t>
-            </a:r>
-          </a:p>
-          <a:p>
-            <a:pPr marL="190500" indent="-190500">
-              <a:spcBef>
-                <a:spcPts val="400"/>
-              </a:spcBef>
-              <a:spcAft>
-                <a:spcPts val="200"/>
-              </a:spcAft>
-            </a:pPr>
-            <a:r>
-              <a:rPr sz="1400">
-                <a:solidFill>
-                  <a:srgbClr val="3D5466"/>
-                </a:solidFill>
-                <a:latin typeface="Arial"/>
-              </a:rPr>
-              <a:t>▸  Berater A will „bis Mittag" eine Engagementübersicht für einen spontanen Termin.</a:t>
-            </a:r>
-          </a:p>
-          <a:p>
-            <a:pPr marL="190500" indent="-190500">
-              <a:spcBef>
-                <a:spcPts val="400"/>
-              </a:spcBef>
-              <a:spcAft>
-                <a:spcPts val="200"/>
-              </a:spcAft>
-            </a:pPr>
-            <a:r>
-              <a:rPr sz="1400">
-                <a:solidFill>
-                  <a:srgbClr val="3D5466"/>
-                </a:solidFill>
-                <a:latin typeface="Arial"/>
-              </a:rPr>
-              <a:t>▸  Berater B hat Ihnen gestern per Zuruf einen Auftrag gegeben, den Sie anders verstanden haben als gemeint – jetzt ist er verärgert.</a:t>
-            </a:r>
-          </a:p>
-          <a:p>
-            <a:pPr marL="190500" indent="-190500">
-              <a:spcBef>
-                <a:spcPts val="400"/>
-              </a:spcBef>
-              <a:spcAft>
-                <a:spcPts val="200"/>
-              </a:spcAft>
-            </a:pPr>
-            <a:r>
-              <a:rPr sz="1400">
-                <a:solidFill>
-                  <a:srgbClr val="3D5466"/>
-                </a:solidFill>
-                <a:latin typeface="Arial"/>
-              </a:rPr>
-              <a:t>▸  Berater C bittet „wenn Zeit ist" um eine Datenpflege.</a:t>
-            </a:r>
-          </a:p>
-        </p:txBody>
-      </p:sp>
-      <p:sp>
-        <p:nvSpPr>
-          <p:cNvPr id="9" name="Rectangle 8"/>
-          <p:cNvSpPr/>
-          <p:nvPr/>
-        </p:nvSpPr>
-        <p:spPr>
-          <a:xfrm>
-            <a:off x="685800" y="5486400"/>
-            <a:ext cx="10817352" cy="640080"/>
-          </a:xfrm>
-          <a:prstGeom prst="rect">
-            <a:avLst/>
-          </a:prstGeom>
-          <a:solidFill>
-            <a:srgbClr val="1F2C56"/>
-          </a:solidFill>
-          <a:ln>
-            <a:noFill/>
-          </a:ln>
-        </p:spPr>
-        <p:style>
-          <a:lnRef idx="1">
-            <a:schemeClr val="accent1"/>
-          </a:lnRef>
-          <a:fillRef idx="3">
-            <a:schemeClr val="accent1"/>
-          </a:fillRef>
-          <a:effectRef idx="2">
-            <a:schemeClr val="accent1"/>
-          </a:effectRef>
-          <a:fontRef idx="minor">
-            <a:schemeClr val="lt1"/>
-          </a:fontRef>
-        </p:style>
-        <p:txBody>
-          <a:bodyPr rtlCol="0" anchor="ctr"/>
-          <a:lstStyle/>
-          <a:p>
-            <a:pPr algn="ctr"/>
-          </a:p>
-        </p:txBody>
-      </p:sp>
-      <p:sp>
-        <p:nvSpPr>
-          <p:cNvPr id="10" name="TextBox 9"/>
-          <p:cNvSpPr txBox="1"/>
-          <p:nvPr/>
-        </p:nvSpPr>
-        <p:spPr>
-          <a:xfrm>
-            <a:off x="868680" y="5596128"/>
-            <a:ext cx="10451592" cy="457200"/>
-          </a:xfrm>
-          <a:prstGeom prst="rect">
-            <a:avLst/>
-          </a:prstGeom>
-          <a:noFill/>
-        </p:spPr>
-        <p:txBody>
-          <a:bodyPr wrap="square">
-            <a:spAutoFit/>
-          </a:bodyPr>
-          <a:lstStyle/>
-          <a:p>
-            <a:pPr algn="l"/>
-            <a:r>
-              <a:rPr sz="1300" b="1" i="0">
-                <a:solidFill>
-                  <a:srgbClr val="FFFFFF"/>
-                </a:solidFill>
-                <a:latin typeface="Arial"/>
-              </a:rPr>
-              <a:t>→  Bearbeitung im Teilnehmer-Workbook (Arbeitsblatt mit Ausfüllfeldern)</a:t>
-            </a:r>
-          </a:p>
-        </p:txBody>
-      </p:sp>
-      <p:sp>
-        <p:nvSpPr>
-          <p:cNvPr id="11" name="Rectangle 10"/>
+      <p:pic>
+        <p:nvPicPr>
+          <p:cNvPr id="7" name="Picture 6" descr="image.png"/>
+          <p:cNvPicPr>
+            <a:picLocks noChangeAspect="1"/>
+          </p:cNvPicPr>
+          <p:nvPr/>
+        </p:nvPicPr>
+        <p:blipFill>
+          <a:blip r:embed="rId2"/>
+          <a:stretch>
+            <a:fillRect/>
+          </a:stretch>
+        </p:blipFill>
+        <p:spPr>
+          <a:xfrm>
+            <a:off x="2009463" y="1325880"/>
+            <a:ext cx="8170026" cy="4937760"/>
+          </a:xfrm>
+          <a:prstGeom prst="rect">
+            <a:avLst/>
+          </a:prstGeom>
+        </p:spPr>
+      </p:pic>
+      <p:sp>
+        <p:nvSpPr>
+          <p:cNvPr id="8" name="Rectangle 7"/>
           <p:cNvSpPr/>
           <p:nvPr/>
         </p:nvSpPr>
@@ -7140,7 +9833,7 @@
       </p:sp>
       <p:sp>
         <p:nvSpPr>
-          <p:cNvPr id="12" name="TextBox 11"/>
+          <p:cNvPr id="9" name="TextBox 8"/>
           <p:cNvSpPr txBox="1"/>
           <p:nvPr/>
         </p:nvSpPr>
@@ -7169,6 +9862,41 @@
                 <a:latin typeface="Consolas"/>
               </a:rPr>
               <a:t>FKB Campus  ·  VA07</a:t>
+            </a:r>
+          </a:p>
+        </p:txBody>
+      </p:sp>
+      <p:sp>
+        <p:nvSpPr>
+          <p:cNvPr id="10" name="TextBox 9"/>
+          <p:cNvSpPr txBox="1"/>
+          <p:nvPr/>
+        </p:nvSpPr>
+        <p:spPr>
+          <a:xfrm>
+            <a:off x="7176211" y="6583680"/>
+            <a:ext cx="4326940" cy="256032"/>
+          </a:xfrm>
+          <a:prstGeom prst="rect">
+            <a:avLst/>
+          </a:prstGeom>
+          <a:noFill/>
+        </p:spPr>
+        <p:txBody>
+          <a:bodyPr wrap="none">
+            <a:spAutoFit/>
+          </a:bodyPr>
+          <a:lstStyle/>
+          <a:p>
+            <a:pPr algn="r"/>
+            <a:r>
+              <a:rPr sz="700">
+                <a:solidFill>
+                  <a:srgbClr val="A0B4D2"/>
+                </a:solidFill>
+                <a:latin typeface="Consolas"/>
+              </a:rPr>
+              <a:t>Schaubild</a:t>
             </a:r>
           </a:p>
         </p:txBody>
@@ -7206,6 +9934,250 @@
             <a:avLst/>
           </a:prstGeom>
           <a:solidFill>
+            <a:srgbClr val="1F2C56"/>
+          </a:solidFill>
+          <a:ln>
+            <a:noFill/>
+          </a:ln>
+        </p:spPr>
+        <p:style>
+          <a:lnRef idx="1">
+            <a:schemeClr val="accent1"/>
+          </a:lnRef>
+          <a:fillRef idx="3">
+            <a:schemeClr val="accent1"/>
+          </a:fillRef>
+          <a:effectRef idx="2">
+            <a:schemeClr val="accent1"/>
+          </a:effectRef>
+          <a:fontRef idx="minor">
+            <a:schemeClr val="lt1"/>
+          </a:fontRef>
+        </p:style>
+        <p:txBody>
+          <a:bodyPr rtlCol="0" anchor="ctr"/>
+          <a:lstStyle/>
+          <a:p>
+            <a:pPr algn="ctr"/>
+          </a:p>
+        </p:txBody>
+      </p:sp>
+      <p:sp>
+        <p:nvSpPr>
+          <p:cNvPr id="3" name="TextBox 2"/>
+          <p:cNvSpPr txBox="1"/>
+          <p:nvPr/>
+        </p:nvSpPr>
+        <p:spPr>
+          <a:xfrm>
+            <a:off x="685800" y="2377440"/>
+            <a:ext cx="10817352" cy="365760"/>
+          </a:xfrm>
+          <a:prstGeom prst="rect">
+            <a:avLst/>
+          </a:prstGeom>
+          <a:noFill/>
+        </p:spPr>
+        <p:txBody>
+          <a:bodyPr wrap="none">
+            <a:spAutoFit/>
+          </a:bodyPr>
+          <a:lstStyle/>
+          <a:p>
+            <a:pPr algn="l"/>
+            <a:r>
+              <a:rPr sz="1200">
+                <a:solidFill>
+                  <a:srgbClr val="D9C089"/>
+                </a:solidFill>
+                <a:latin typeface="Consolas"/>
+              </a:rPr>
+              <a:t>00:20–00:30</a:t>
+            </a:r>
+          </a:p>
+        </p:txBody>
+      </p:sp>
+      <p:sp>
+        <p:nvSpPr>
+          <p:cNvPr id="4" name="Rectangle 3"/>
+          <p:cNvSpPr/>
+          <p:nvPr/>
+        </p:nvSpPr>
+        <p:spPr>
+          <a:xfrm>
+            <a:off x="685800" y="2788920"/>
+            <a:ext cx="548640" cy="38100"/>
+          </a:xfrm>
+          <a:prstGeom prst="rect">
+            <a:avLst/>
+          </a:prstGeom>
+          <a:solidFill>
+            <a:srgbClr val="D9C089"/>
+          </a:solidFill>
+          <a:ln>
+            <a:noFill/>
+          </a:ln>
+        </p:spPr>
+        <p:style>
+          <a:lnRef idx="1">
+            <a:schemeClr val="accent1"/>
+          </a:lnRef>
+          <a:fillRef idx="3">
+            <a:schemeClr val="accent1"/>
+          </a:fillRef>
+          <a:effectRef idx="2">
+            <a:schemeClr val="accent1"/>
+          </a:effectRef>
+          <a:fontRef idx="minor">
+            <a:schemeClr val="lt1"/>
+          </a:fontRef>
+        </p:style>
+        <p:txBody>
+          <a:bodyPr rtlCol="0" anchor="ctr"/>
+          <a:lstStyle/>
+          <a:p>
+            <a:pPr algn="ctr"/>
+          </a:p>
+        </p:txBody>
+      </p:sp>
+      <p:sp>
+        <p:nvSpPr>
+          <p:cNvPr id="5" name="TextBox 4"/>
+          <p:cNvSpPr txBox="1"/>
+          <p:nvPr/>
+        </p:nvSpPr>
+        <p:spPr>
+          <a:xfrm>
+            <a:off x="685800" y="3017520"/>
+            <a:ext cx="10817352" cy="1463040"/>
+          </a:xfrm>
+          <a:prstGeom prst="rect">
+            <a:avLst/>
+          </a:prstGeom>
+          <a:noFill/>
+        </p:spPr>
+        <p:txBody>
+          <a:bodyPr wrap="square">
+            <a:spAutoFit/>
+          </a:bodyPr>
+          <a:lstStyle/>
+          <a:p>
+            <a:pPr algn="l"/>
+            <a:r>
+              <a:rPr sz="4000" b="1" i="0">
+                <a:solidFill>
+                  <a:srgbClr val="FFFFFF"/>
+                </a:solidFill>
+                <a:latin typeface="Arial"/>
+              </a:rPr>
+              <a:t>Theorie-Input 2</a:t>
+            </a:r>
+          </a:p>
+        </p:txBody>
+      </p:sp>
+      <p:sp>
+        <p:nvSpPr>
+          <p:cNvPr id="6" name="TextBox 5"/>
+          <p:cNvSpPr txBox="1"/>
+          <p:nvPr/>
+        </p:nvSpPr>
+        <p:spPr>
+          <a:xfrm>
+            <a:off x="685800" y="4480560"/>
+            <a:ext cx="8653881" cy="1280160"/>
+          </a:xfrm>
+          <a:prstGeom prst="rect">
+            <a:avLst/>
+          </a:prstGeom>
+          <a:noFill/>
+        </p:spPr>
+        <p:txBody>
+          <a:bodyPr wrap="square">
+            <a:spAutoFit/>
+          </a:bodyPr>
+          <a:lstStyle/>
+          <a:p>
+            <a:pPr algn="l"/>
+            <a:r>
+              <a:rPr sz="1600" b="0" i="0">
+                <a:solidFill>
+                  <a:srgbClr val="C8D2E6"/>
+                </a:solidFill>
+                <a:latin typeface="Arial"/>
+              </a:rPr>
+              <a:t>Ein Zuruf hat vier Seiten – explizite Regeln entlasten die Beziehung.</a:t>
+            </a:r>
+          </a:p>
+        </p:txBody>
+      </p:sp>
+      <p:sp>
+        <p:nvSpPr>
+          <p:cNvPr id="7" name="TextBox 6"/>
+          <p:cNvSpPr txBox="1"/>
+          <p:nvPr/>
+        </p:nvSpPr>
+        <p:spPr>
+          <a:xfrm>
+            <a:off x="685800" y="6355080"/>
+            <a:ext cx="10817352" cy="274320"/>
+          </a:xfrm>
+          <a:prstGeom prst="rect">
+            <a:avLst/>
+          </a:prstGeom>
+          <a:noFill/>
+        </p:spPr>
+        <p:txBody>
+          <a:bodyPr wrap="none">
+            <a:spAutoFit/>
+          </a:bodyPr>
+          <a:lstStyle/>
+          <a:p>
+            <a:pPr algn="l"/>
+            <a:r>
+              <a:rPr sz="700">
+                <a:solidFill>
+                  <a:srgbClr val="8CA0C3"/>
+                </a:solidFill>
+                <a:latin typeface="Consolas"/>
+              </a:rPr>
+              <a:t>FKB Campus  ·  VA07</a:t>
+            </a:r>
+          </a:p>
+        </p:txBody>
+      </p:sp>
+    </p:spTree>
+  </p:cSld>
+  <p:clrMapOvr>
+    <a:masterClrMapping/>
+  </p:clrMapOvr>
+</p:sld>
+</file>
+
+<file path=ppt/slides/slide9.xml><?xml version="1.0" encoding="utf-8"?>
+<p:sld xmlns:a="http://schemas.openxmlformats.org/drawingml/2006/main" xmlns:p="http://schemas.openxmlformats.org/presentationml/2006/main" xmlns:r="http://schemas.openxmlformats.org/officeDocument/2006/relationships">
+  <p:cSld>
+    <p:spTree>
+      <p:nvGrpSpPr>
+        <p:cNvPr id="1" name=""/>
+        <p:cNvGrpSpPr/>
+        <p:nvPr/>
+      </p:nvGrpSpPr>
+      <p:grpSpPr/>
+      <p:sp>
+        <p:nvSpPr>
+          <p:cNvPr id="2" name="Rectangle 1"/>
+          <p:cNvSpPr/>
+          <p:nvPr/>
+        </p:nvSpPr>
+        <p:spPr>
+          <a:xfrm>
+            <a:off x="0" y="0"/>
+            <a:ext cx="12188952" cy="6858000"/>
+          </a:xfrm>
+          <a:prstGeom prst="rect">
+            <a:avLst/>
+          </a:prstGeom>
+          <a:solidFill>
             <a:srgbClr val="EDEDF3"/>
           </a:solidFill>
           <a:ln>
@@ -7428,7 +10400,7 @@
                 </a:solidFill>
                 <a:latin typeface="Arial"/>
               </a:rPr>
-              <a:t>Reflexionsfragen</a:t>
+              <a:t>Warum explizite Regeln entlasten</a:t>
             </a:r>
           </a:p>
         </p:txBody>
@@ -7454,6 +10426,25 @@
             <a:spAutoFit/>
           </a:bodyPr>
           <a:lstStyle/>
+          <a:p>
+            <a:pPr marL="177800" indent="-177800">
+              <a:spcBef>
+                <a:spcPts val="600"/>
+              </a:spcBef>
+              <a:spcAft>
+                <a:spcPts val="200"/>
+              </a:spcAft>
+            </a:pPr>
+            <a:r>
+              <a:rPr sz="1200" i="1">
+                <a:solidFill>
+                  <a:srgbClr val="3D5466"/>
+                </a:solidFill>
+                <a:latin typeface="Arial"/>
+              </a:rPr>
+              <a:t>→  Ein Zuruf wie „sofort!" enthält vier Ebenen (Schulz von Thun). Explizite Übergaberegeln entlasten die Beziehungsebene.</a:t>
+            </a:r>
+          </a:p>
           <a:p>
             <a:pPr marL="190500" indent="-190500">
               <a:spcBef>
@@ -7470,7 +10461,7 @@
                 </a:solidFill>
                 <a:latin typeface="Arial"/>
               </a:rPr>
-              <a:t>▸  An welcher Stelle ist die Zuständigkeit zwischen Ihnen und Ihren Beratern am unklarsten?</a:t>
+              <a:t>▸  Was meint der Berater – die Sache, die Beziehung oder den Appell?</a:t>
             </a:r>
           </a:p>
           <a:p>
@@ -7489,7 +10480,7 @@
                 </a:solidFill>
                 <a:latin typeface="Arial"/>
               </a:rPr>
-              <a:t>▸  Welche Regel würde Ihre Zusammenarbeit am meisten verbessern – und warum gibt es sie noch nicht?</a:t>
+              <a:t>▸  Übergaberegeln klären: Was wird wie und wann übergeben?</a:t>
             </a:r>
           </a:p>
           <a:p>
@@ -7508,26 +10499,7 @@
                 </a:solidFill>
                 <a:latin typeface="Arial"/>
               </a:rPr>
-              <a:t>▸  Wie reagieren Sie heute, wenn alles gleichzeitig „dringend" ist?</a:t>
-            </a:r>
-          </a:p>
-          <a:p>
-            <a:pPr marL="190500" indent="-190500">
-              <a:spcBef>
-                <a:spcPts val="400"/>
-              </a:spcBef>
-              <a:spcAft>
-                <a:spcPts val="200"/>
-              </a:spcAft>
-            </a:pPr>
-            <a:r>
-              <a:rPr sz="1300">
-                <a:solidFill>
-                  <a:srgbClr val="3D5466"/>
-                </a:solidFill>
-                <a:latin typeface="Arial"/>
-              </a:rPr>
-              <a:t>▸  Wie signalisieren Sie Ihrem Teamleiter, wenn die Auftragsflut aller Berater Ihre Kapazität dauerhaft übersteigt? Haben Sie eine Sprache dafür – und nutzen Sie sie?</a:t>
+              <a:t>▸  Grundregel: Auftrag immer ins System, nicht per Zuruf – und das Verständnis kurz rückbestätigen.</a:t>
             </a:r>
           </a:p>
         </p:txBody>

</xml_diff>